<commit_message>
Update client reports, ignore luxeenv, add pymongo to requirements
Co-Authored-By: Claude Sonnet 5 <noreply@anthropic.com>
</commit_message>
<xml_diff>
--- a/Client reports/LUXE-AI-Assistant-Presentation.pptx
+++ b/Client reports/LUXE-AI-Assistant-Presentation.pptx
@@ -5,19 +5,19 @@
     <p:sldMasterId id="2147483648" r:id="rId1"/>
   </p:sldMasterIdLst>
   <p:sldIdLst>
-    <p:sldId id="256" r:id="rId7"/>
-    <p:sldId id="257" r:id="rId8"/>
-    <p:sldId id="258" r:id="rId9"/>
-    <p:sldId id="259" r:id="rId10"/>
-    <p:sldId id="260" r:id="rId11"/>
-    <p:sldId id="261" r:id="rId12"/>
-    <p:sldId id="262" r:id="rId13"/>
-    <p:sldId id="263" r:id="rId14"/>
-    <p:sldId id="264" r:id="rId15"/>
-    <p:sldId id="265" r:id="rId16"/>
-    <p:sldId id="266" r:id="rId17"/>
+    <p:sldId id="256" r:id="rId2"/>
+    <p:sldId id="257" r:id="rId3"/>
+    <p:sldId id="258" r:id="rId4"/>
+    <p:sldId id="259" r:id="rId5"/>
+    <p:sldId id="260" r:id="rId6"/>
+    <p:sldId id="261" r:id="rId7"/>
+    <p:sldId id="262" r:id="rId8"/>
+    <p:sldId id="263" r:id="rId9"/>
+    <p:sldId id="264" r:id="rId10"/>
+    <p:sldId id="265" r:id="rId11"/>
+    <p:sldId id="266" r:id="rId12"/>
   </p:sldIdLst>
-  <p:sldSz cx="12191695" cy="6858000" type="screen4x3"/>
+  <p:sldSz cx="12192000" cy="6858000"/>
   <p:notesSz cx="6858000" cy="9144000"/>
   <p:defaultTextStyle>
     <a:defPPr>
@@ -114,6 +114,22 @@
       </a:defRPr>
     </a:lvl9pPr>
   </p:defaultTextStyle>
+  <p:extLst>
+    <p:ext uri="{EFAFB233-063F-42B5-8137-9DF3F51BA10A}">
+      <p15:sldGuideLst xmlns:p15="http://schemas.microsoft.com/office/powerpoint/2012/main">
+        <p15:guide id="1" orient="horz" pos="2160">
+          <p15:clr>
+            <a:srgbClr val="A4A3A4"/>
+          </p15:clr>
+        </p15:guide>
+        <p15:guide id="2" pos="2880">
+          <p15:clr>
+            <a:srgbClr val="A4A3A4"/>
+          </p15:clr>
+        </p15:guide>
+      </p15:sldGuideLst>
+    </p:ext>
+  </p:extLst>
 </p:presentation>
 </file>
 
@@ -155,10 +171,9 @@
           <a:lstStyle/>
           <a:p>
             <a:r>
-              <a:rPr lang="en-US" smtClean="0"/>
+              <a:rPr lang="en-US"/>
               <a:t>Click to edit Master title style</a:t>
             </a:r>
-            <a:endParaRPr lang="en-US"/>
           </a:p>
         </p:txBody>
       </p:sp>
@@ -274,10 +289,9 @@
           </a:lstStyle>
           <a:p>
             <a:r>
-              <a:rPr lang="en-US" smtClean="0"/>
+              <a:rPr lang="en-US"/>
               <a:t>Click to edit Master subtitle style</a:t>
             </a:r>
-            <a:endParaRPr lang="en-US"/>
           </a:p>
         </p:txBody>
       </p:sp>
@@ -298,7 +312,7 @@
           <a:p>
             <a:fld id="{5BCAD085-E8A6-8845-BD4E-CB4CCA059FC4}" type="datetimeFigureOut">
               <a:rPr lang="en-US" smtClean="0"/>
-              <a:t>1/27/13</a:t>
+              <a:t>9/11/2026</a:t>
             </a:fld>
             <a:endParaRPr lang="en-US"/>
           </a:p>
@@ -392,10 +406,9 @@
           <a:lstStyle/>
           <a:p>
             <a:r>
-              <a:rPr lang="en-US" smtClean="0"/>
+              <a:rPr lang="en-US"/>
               <a:t>Click to edit Master title style</a:t>
             </a:r>
-            <a:endParaRPr lang="en-US"/>
           </a:p>
         </p:txBody>
       </p:sp>
@@ -416,38 +429,37 @@
           <a:p>
             <a:pPr lvl="0"/>
             <a:r>
-              <a:rPr lang="en-US" smtClean="0"/>
+              <a:rPr lang="en-US"/>
               <a:t>Click to edit Master text styles</a:t>
             </a:r>
           </a:p>
           <a:p>
             <a:pPr lvl="1"/>
             <a:r>
-              <a:rPr lang="en-US" smtClean="0"/>
+              <a:rPr lang="en-US"/>
               <a:t>Second level</a:t>
             </a:r>
           </a:p>
           <a:p>
             <a:pPr lvl="2"/>
             <a:r>
-              <a:rPr lang="en-US" smtClean="0"/>
+              <a:rPr lang="en-US"/>
               <a:t>Third level</a:t>
             </a:r>
           </a:p>
           <a:p>
             <a:pPr lvl="3"/>
             <a:r>
-              <a:rPr lang="en-US" smtClean="0"/>
+              <a:rPr lang="en-US"/>
               <a:t>Fourth level</a:t>
             </a:r>
           </a:p>
           <a:p>
             <a:pPr lvl="4"/>
             <a:r>
-              <a:rPr lang="en-US" smtClean="0"/>
+              <a:rPr lang="en-US"/>
               <a:t>Fifth level</a:t>
             </a:r>
-            <a:endParaRPr lang="en-US"/>
           </a:p>
         </p:txBody>
       </p:sp>
@@ -468,7 +480,7 @@
           <a:p>
             <a:fld id="{5BCAD085-E8A6-8845-BD4E-CB4CCA059FC4}" type="datetimeFigureOut">
               <a:rPr lang="en-US" smtClean="0"/>
-              <a:t>1/27/13</a:t>
+              <a:t>9/11/2026</a:t>
             </a:fld>
             <a:endParaRPr lang="en-US"/>
           </a:p>
@@ -567,10 +579,9 @@
           <a:lstStyle/>
           <a:p>
             <a:r>
-              <a:rPr lang="en-US" smtClean="0"/>
+              <a:rPr lang="en-US"/>
               <a:t>Click to edit Master title style</a:t>
             </a:r>
-            <a:endParaRPr lang="en-US"/>
           </a:p>
         </p:txBody>
       </p:sp>
@@ -596,38 +607,37 @@
           <a:p>
             <a:pPr lvl="0"/>
             <a:r>
-              <a:rPr lang="en-US" smtClean="0"/>
+              <a:rPr lang="en-US"/>
               <a:t>Click to edit Master text styles</a:t>
             </a:r>
           </a:p>
           <a:p>
             <a:pPr lvl="1"/>
             <a:r>
-              <a:rPr lang="en-US" smtClean="0"/>
+              <a:rPr lang="en-US"/>
               <a:t>Second level</a:t>
             </a:r>
           </a:p>
           <a:p>
             <a:pPr lvl="2"/>
             <a:r>
-              <a:rPr lang="en-US" smtClean="0"/>
+              <a:rPr lang="en-US"/>
               <a:t>Third level</a:t>
             </a:r>
           </a:p>
           <a:p>
             <a:pPr lvl="3"/>
             <a:r>
-              <a:rPr lang="en-US" smtClean="0"/>
+              <a:rPr lang="en-US"/>
               <a:t>Fourth level</a:t>
             </a:r>
           </a:p>
           <a:p>
             <a:pPr lvl="4"/>
             <a:r>
-              <a:rPr lang="en-US" smtClean="0"/>
+              <a:rPr lang="en-US"/>
               <a:t>Fifth level</a:t>
             </a:r>
-            <a:endParaRPr lang="en-US"/>
           </a:p>
         </p:txBody>
       </p:sp>
@@ -648,7 +658,7 @@
           <a:p>
             <a:fld id="{5BCAD085-E8A6-8845-BD4E-CB4CCA059FC4}" type="datetimeFigureOut">
               <a:rPr lang="en-US" smtClean="0"/>
-              <a:t>1/27/13</a:t>
+              <a:t>9/11/2026</a:t>
             </a:fld>
             <a:endParaRPr lang="en-US"/>
           </a:p>
@@ -742,10 +752,9 @@
           <a:lstStyle/>
           <a:p>
             <a:r>
-              <a:rPr lang="en-US" smtClean="0"/>
+              <a:rPr lang="en-US"/>
               <a:t>Click to edit Master title style</a:t>
             </a:r>
-            <a:endParaRPr lang="en-US"/>
           </a:p>
         </p:txBody>
       </p:sp>
@@ -766,38 +775,37 @@
           <a:p>
             <a:pPr lvl="0"/>
             <a:r>
-              <a:rPr lang="en-US" smtClean="0"/>
+              <a:rPr lang="en-US"/>
               <a:t>Click to edit Master text styles</a:t>
             </a:r>
           </a:p>
           <a:p>
             <a:pPr lvl="1"/>
             <a:r>
-              <a:rPr lang="en-US" smtClean="0"/>
+              <a:rPr lang="en-US"/>
               <a:t>Second level</a:t>
             </a:r>
           </a:p>
           <a:p>
             <a:pPr lvl="2"/>
             <a:r>
-              <a:rPr lang="en-US" smtClean="0"/>
+              <a:rPr lang="en-US"/>
               <a:t>Third level</a:t>
             </a:r>
           </a:p>
           <a:p>
             <a:pPr lvl="3"/>
             <a:r>
-              <a:rPr lang="en-US" smtClean="0"/>
+              <a:rPr lang="en-US"/>
               <a:t>Fourth level</a:t>
             </a:r>
           </a:p>
           <a:p>
             <a:pPr lvl="4"/>
             <a:r>
-              <a:rPr lang="en-US" smtClean="0"/>
+              <a:rPr lang="en-US"/>
               <a:t>Fifth level</a:t>
             </a:r>
-            <a:endParaRPr lang="en-US"/>
           </a:p>
         </p:txBody>
       </p:sp>
@@ -818,7 +826,7 @@
           <a:p>
             <a:fld id="{5BCAD085-E8A6-8845-BD4E-CB4CCA059FC4}" type="datetimeFigureOut">
               <a:rPr lang="en-US" smtClean="0"/>
-              <a:t>1/27/13</a:t>
+              <a:t>9/11/2026</a:t>
             </a:fld>
             <a:endParaRPr lang="en-US"/>
           </a:p>
@@ -921,10 +929,9 @@
           </a:lstStyle>
           <a:p>
             <a:r>
-              <a:rPr lang="en-US" smtClean="0"/>
+              <a:rPr lang="en-US"/>
               <a:t>Click to edit Master title style</a:t>
             </a:r>
-            <a:endParaRPr lang="en-US"/>
           </a:p>
         </p:txBody>
       </p:sp>
@@ -1041,7 +1048,7 @@
           <a:p>
             <a:pPr lvl="0"/>
             <a:r>
-              <a:rPr lang="en-US" smtClean="0"/>
+              <a:rPr lang="en-US"/>
               <a:t>Click to edit Master text styles</a:t>
             </a:r>
           </a:p>
@@ -1064,7 +1071,7 @@
           <a:p>
             <a:fld id="{5BCAD085-E8A6-8845-BD4E-CB4CCA059FC4}" type="datetimeFigureOut">
               <a:rPr lang="en-US" smtClean="0"/>
-              <a:t>1/27/13</a:t>
+              <a:t>9/11/2026</a:t>
             </a:fld>
             <a:endParaRPr lang="en-US"/>
           </a:p>
@@ -1158,10 +1165,9 @@
           <a:lstStyle/>
           <a:p>
             <a:r>
-              <a:rPr lang="en-US" smtClean="0"/>
+              <a:rPr lang="en-US"/>
               <a:t>Click to edit Master title style</a:t>
             </a:r>
-            <a:endParaRPr lang="en-US"/>
           </a:p>
         </p:txBody>
       </p:sp>
@@ -1215,38 +1221,37 @@
           <a:p>
             <a:pPr lvl="0"/>
             <a:r>
-              <a:rPr lang="en-US" smtClean="0"/>
+              <a:rPr lang="en-US"/>
               <a:t>Click to edit Master text styles</a:t>
             </a:r>
           </a:p>
           <a:p>
             <a:pPr lvl="1"/>
             <a:r>
-              <a:rPr lang="en-US" smtClean="0"/>
+              <a:rPr lang="en-US"/>
               <a:t>Second level</a:t>
             </a:r>
           </a:p>
           <a:p>
             <a:pPr lvl="2"/>
             <a:r>
-              <a:rPr lang="en-US" smtClean="0"/>
+              <a:rPr lang="en-US"/>
               <a:t>Third level</a:t>
             </a:r>
           </a:p>
           <a:p>
             <a:pPr lvl="3"/>
             <a:r>
-              <a:rPr lang="en-US" smtClean="0"/>
+              <a:rPr lang="en-US"/>
               <a:t>Fourth level</a:t>
             </a:r>
           </a:p>
           <a:p>
             <a:pPr lvl="4"/>
             <a:r>
-              <a:rPr lang="en-US" smtClean="0"/>
+              <a:rPr lang="en-US"/>
               <a:t>Fifth level</a:t>
             </a:r>
-            <a:endParaRPr lang="en-US"/>
           </a:p>
         </p:txBody>
       </p:sp>
@@ -1300,38 +1305,37 @@
           <a:p>
             <a:pPr lvl="0"/>
             <a:r>
-              <a:rPr lang="en-US" smtClean="0"/>
+              <a:rPr lang="en-US"/>
               <a:t>Click to edit Master text styles</a:t>
             </a:r>
           </a:p>
           <a:p>
             <a:pPr lvl="1"/>
             <a:r>
-              <a:rPr lang="en-US" smtClean="0"/>
+              <a:rPr lang="en-US"/>
               <a:t>Second level</a:t>
             </a:r>
           </a:p>
           <a:p>
             <a:pPr lvl="2"/>
             <a:r>
-              <a:rPr lang="en-US" smtClean="0"/>
+              <a:rPr lang="en-US"/>
               <a:t>Third level</a:t>
             </a:r>
           </a:p>
           <a:p>
             <a:pPr lvl="3"/>
             <a:r>
-              <a:rPr lang="en-US" smtClean="0"/>
+              <a:rPr lang="en-US"/>
               <a:t>Fourth level</a:t>
             </a:r>
           </a:p>
           <a:p>
             <a:pPr lvl="4"/>
             <a:r>
-              <a:rPr lang="en-US" smtClean="0"/>
+              <a:rPr lang="en-US"/>
               <a:t>Fifth level</a:t>
             </a:r>
-            <a:endParaRPr lang="en-US"/>
           </a:p>
         </p:txBody>
       </p:sp>
@@ -1352,7 +1356,7 @@
           <a:p>
             <a:fld id="{5BCAD085-E8A6-8845-BD4E-CB4CCA059FC4}" type="datetimeFigureOut">
               <a:rPr lang="en-US" smtClean="0"/>
-              <a:t>1/27/13</a:t>
+              <a:t>9/11/2026</a:t>
             </a:fld>
             <a:endParaRPr lang="en-US"/>
           </a:p>
@@ -1450,10 +1454,9 @@
           </a:lstStyle>
           <a:p>
             <a:r>
-              <a:rPr lang="en-US" smtClean="0"/>
+              <a:rPr lang="en-US"/>
               <a:t>Click to edit Master title style</a:t>
             </a:r>
-            <a:endParaRPr lang="en-US"/>
           </a:p>
         </p:txBody>
       </p:sp>
@@ -1516,7 +1519,7 @@
           <a:p>
             <a:pPr lvl="0"/>
             <a:r>
-              <a:rPr lang="en-US" smtClean="0"/>
+              <a:rPr lang="en-US"/>
               <a:t>Click to edit Master text styles</a:t>
             </a:r>
           </a:p>
@@ -1572,38 +1575,37 @@
           <a:p>
             <a:pPr lvl="0"/>
             <a:r>
-              <a:rPr lang="en-US" smtClean="0"/>
+              <a:rPr lang="en-US"/>
               <a:t>Click to edit Master text styles</a:t>
             </a:r>
           </a:p>
           <a:p>
             <a:pPr lvl="1"/>
             <a:r>
-              <a:rPr lang="en-US" smtClean="0"/>
+              <a:rPr lang="en-US"/>
               <a:t>Second level</a:t>
             </a:r>
           </a:p>
           <a:p>
             <a:pPr lvl="2"/>
             <a:r>
-              <a:rPr lang="en-US" smtClean="0"/>
+              <a:rPr lang="en-US"/>
               <a:t>Third level</a:t>
             </a:r>
           </a:p>
           <a:p>
             <a:pPr lvl="3"/>
             <a:r>
-              <a:rPr lang="en-US" smtClean="0"/>
+              <a:rPr lang="en-US"/>
               <a:t>Fourth level</a:t>
             </a:r>
           </a:p>
           <a:p>
             <a:pPr lvl="4"/>
             <a:r>
-              <a:rPr lang="en-US" smtClean="0"/>
+              <a:rPr lang="en-US"/>
               <a:t>Fifth level</a:t>
             </a:r>
-            <a:endParaRPr lang="en-US"/>
           </a:p>
         </p:txBody>
       </p:sp>
@@ -1666,7 +1668,7 @@
           <a:p>
             <a:pPr lvl="0"/>
             <a:r>
-              <a:rPr lang="en-US" smtClean="0"/>
+              <a:rPr lang="en-US"/>
               <a:t>Click to edit Master text styles</a:t>
             </a:r>
           </a:p>
@@ -1722,38 +1724,37 @@
           <a:p>
             <a:pPr lvl="0"/>
             <a:r>
-              <a:rPr lang="en-US" smtClean="0"/>
+              <a:rPr lang="en-US"/>
               <a:t>Click to edit Master text styles</a:t>
             </a:r>
           </a:p>
           <a:p>
             <a:pPr lvl="1"/>
             <a:r>
-              <a:rPr lang="en-US" smtClean="0"/>
+              <a:rPr lang="en-US"/>
               <a:t>Second level</a:t>
             </a:r>
           </a:p>
           <a:p>
             <a:pPr lvl="2"/>
             <a:r>
-              <a:rPr lang="en-US" smtClean="0"/>
+              <a:rPr lang="en-US"/>
               <a:t>Third level</a:t>
             </a:r>
           </a:p>
           <a:p>
             <a:pPr lvl="3"/>
             <a:r>
-              <a:rPr lang="en-US" smtClean="0"/>
+              <a:rPr lang="en-US"/>
               <a:t>Fourth level</a:t>
             </a:r>
           </a:p>
           <a:p>
             <a:pPr lvl="4"/>
             <a:r>
-              <a:rPr lang="en-US" smtClean="0"/>
+              <a:rPr lang="en-US"/>
               <a:t>Fifth level</a:t>
             </a:r>
-            <a:endParaRPr lang="en-US"/>
           </a:p>
         </p:txBody>
       </p:sp>
@@ -1774,7 +1775,7 @@
           <a:p>
             <a:fld id="{5BCAD085-E8A6-8845-BD4E-CB4CCA059FC4}" type="datetimeFigureOut">
               <a:rPr lang="en-US" smtClean="0"/>
-              <a:t>1/27/13</a:t>
+              <a:t>9/11/2026</a:t>
             </a:fld>
             <a:endParaRPr lang="en-US"/>
           </a:p>
@@ -1868,10 +1869,9 @@
           <a:lstStyle/>
           <a:p>
             <a:r>
-              <a:rPr lang="en-US" smtClean="0"/>
+              <a:rPr lang="en-US"/>
               <a:t>Click to edit Master title style</a:t>
             </a:r>
-            <a:endParaRPr lang="en-US"/>
           </a:p>
         </p:txBody>
       </p:sp>
@@ -1892,7 +1892,7 @@
           <a:p>
             <a:fld id="{5BCAD085-E8A6-8845-BD4E-CB4CCA059FC4}" type="datetimeFigureOut">
               <a:rPr lang="en-US" smtClean="0"/>
-              <a:t>1/27/13</a:t>
+              <a:t>9/11/2026</a:t>
             </a:fld>
             <a:endParaRPr lang="en-US"/>
           </a:p>
@@ -1987,7 +1987,7 @@
           <a:p>
             <a:fld id="{5BCAD085-E8A6-8845-BD4E-CB4CCA059FC4}" type="datetimeFigureOut">
               <a:rPr lang="en-US" smtClean="0"/>
-              <a:t>1/27/13</a:t>
+              <a:t>9/11/2026</a:t>
             </a:fld>
             <a:endParaRPr lang="en-US"/>
           </a:p>
@@ -2090,10 +2090,9 @@
           </a:lstStyle>
           <a:p>
             <a:r>
-              <a:rPr lang="en-US" smtClean="0"/>
+              <a:rPr lang="en-US"/>
               <a:t>Click to edit Master title style</a:t>
             </a:r>
-            <a:endParaRPr lang="en-US"/>
           </a:p>
         </p:txBody>
       </p:sp>
@@ -2147,38 +2146,37 @@
           <a:p>
             <a:pPr lvl="0"/>
             <a:r>
-              <a:rPr lang="en-US" smtClean="0"/>
+              <a:rPr lang="en-US"/>
               <a:t>Click to edit Master text styles</a:t>
             </a:r>
           </a:p>
           <a:p>
             <a:pPr lvl="1"/>
             <a:r>
-              <a:rPr lang="en-US" smtClean="0"/>
+              <a:rPr lang="en-US"/>
               <a:t>Second level</a:t>
             </a:r>
           </a:p>
           <a:p>
             <a:pPr lvl="2"/>
             <a:r>
-              <a:rPr lang="en-US" smtClean="0"/>
+              <a:rPr lang="en-US"/>
               <a:t>Third level</a:t>
             </a:r>
           </a:p>
           <a:p>
             <a:pPr lvl="3"/>
             <a:r>
-              <a:rPr lang="en-US" smtClean="0"/>
+              <a:rPr lang="en-US"/>
               <a:t>Fourth level</a:t>
             </a:r>
           </a:p>
           <a:p>
             <a:pPr lvl="4"/>
             <a:r>
-              <a:rPr lang="en-US" smtClean="0"/>
+              <a:rPr lang="en-US"/>
               <a:t>Fifth level</a:t>
             </a:r>
-            <a:endParaRPr lang="en-US"/>
           </a:p>
         </p:txBody>
       </p:sp>
@@ -2241,7 +2239,7 @@
           <a:p>
             <a:pPr lvl="0"/>
             <a:r>
-              <a:rPr lang="en-US" smtClean="0"/>
+              <a:rPr lang="en-US"/>
               <a:t>Click to edit Master text styles</a:t>
             </a:r>
           </a:p>
@@ -2264,7 +2262,7 @@
           <a:p>
             <a:fld id="{5BCAD085-E8A6-8845-BD4E-CB4CCA059FC4}" type="datetimeFigureOut">
               <a:rPr lang="en-US" smtClean="0"/>
-              <a:t>1/27/13</a:t>
+              <a:t>9/11/2026</a:t>
             </a:fld>
             <a:endParaRPr lang="en-US"/>
           </a:p>
@@ -2367,10 +2365,9 @@
           </a:lstStyle>
           <a:p>
             <a:r>
-              <a:rPr lang="en-US" smtClean="0"/>
+              <a:rPr lang="en-US"/>
               <a:t>Click to edit Master title style</a:t>
             </a:r>
-            <a:endParaRPr lang="en-US"/>
           </a:p>
         </p:txBody>
       </p:sp>
@@ -2494,7 +2491,7 @@
           <a:p>
             <a:pPr lvl="0"/>
             <a:r>
-              <a:rPr lang="en-US" smtClean="0"/>
+              <a:rPr lang="en-US"/>
               <a:t>Click to edit Master text styles</a:t>
             </a:r>
           </a:p>
@@ -2517,7 +2514,7 @@
           <a:p>
             <a:fld id="{5BCAD085-E8A6-8845-BD4E-CB4CCA059FC4}" type="datetimeFigureOut">
               <a:rPr lang="en-US" smtClean="0"/>
-              <a:t>1/27/13</a:t>
+              <a:t>9/11/2026</a:t>
             </a:fld>
             <a:endParaRPr lang="en-US"/>
           </a:p>
@@ -2626,10 +2623,9 @@
           <a:lstStyle/>
           <a:p>
             <a:r>
-              <a:rPr lang="en-US" smtClean="0"/>
+              <a:rPr lang="en-US"/>
               <a:t>Click to edit Master title style</a:t>
             </a:r>
-            <a:endParaRPr lang="en-US"/>
           </a:p>
         </p:txBody>
       </p:sp>
@@ -2660,38 +2656,37 @@
           <a:p>
             <a:pPr lvl="0"/>
             <a:r>
-              <a:rPr lang="en-US" smtClean="0"/>
+              <a:rPr lang="en-US"/>
               <a:t>Click to edit Master text styles</a:t>
             </a:r>
           </a:p>
           <a:p>
             <a:pPr lvl="1"/>
             <a:r>
-              <a:rPr lang="en-US" smtClean="0"/>
+              <a:rPr lang="en-US"/>
               <a:t>Second level</a:t>
             </a:r>
           </a:p>
           <a:p>
             <a:pPr lvl="2"/>
             <a:r>
-              <a:rPr lang="en-US" smtClean="0"/>
+              <a:rPr lang="en-US"/>
               <a:t>Third level</a:t>
             </a:r>
           </a:p>
           <a:p>
             <a:pPr lvl="3"/>
             <a:r>
-              <a:rPr lang="en-US" smtClean="0"/>
+              <a:rPr lang="en-US"/>
               <a:t>Fourth level</a:t>
             </a:r>
           </a:p>
           <a:p>
             <a:pPr lvl="4"/>
             <a:r>
-              <a:rPr lang="en-US" smtClean="0"/>
+              <a:rPr lang="en-US"/>
               <a:t>Fifth level</a:t>
             </a:r>
-            <a:endParaRPr lang="en-US"/>
           </a:p>
         </p:txBody>
       </p:sp>
@@ -2730,7 +2725,7 @@
           <a:p>
             <a:fld id="{5BCAD085-E8A6-8845-BD4E-CB4CCA059FC4}" type="datetimeFigureOut">
               <a:rPr lang="en-US" smtClean="0"/>
-              <a:t>1/27/13</a:t>
+              <a:t>9/11/2026</a:t>
             </a:fld>
             <a:endParaRPr lang="en-US"/>
           </a:p>
@@ -3089,7 +3084,7 @@
 </file>
 
 <file path=ppt/slides/slide1.xml><?xml version="1.0" encoding="utf-8"?>
-<p:sld xmlns:a="http://schemas.openxmlformats.org/drawingml/2006/main" xmlns:p="http://schemas.openxmlformats.org/presentationml/2006/main" xmlns:r="http://schemas.openxmlformats.org/officeDocument/2006/relationships">
+<p:sld xmlns:a="http://schemas.openxmlformats.org/drawingml/2006/main" xmlns:r="http://schemas.openxmlformats.org/officeDocument/2006/relationships" xmlns:p="http://schemas.openxmlformats.org/presentationml/2006/main">
   <p:cSld>
     <p:spTree>
       <p:nvGrpSpPr>
@@ -3097,7 +3092,14 @@
         <p:cNvGrpSpPr/>
         <p:nvPr/>
       </p:nvGrpSpPr>
-      <p:grpSpPr/>
+      <p:grpSpPr>
+        <a:xfrm>
+          <a:off x="0" y="0"/>
+          <a:ext cx="0" cy="0"/>
+          <a:chOff x="0" y="0"/>
+          <a:chExt cx="0" cy="0"/>
+        </a:xfrm>
+      </p:grpSpPr>
       <p:sp>
         <p:nvSpPr>
           <p:cNvPr id="2" name="Rectangle 1"/>
@@ -3139,6 +3141,7 @@
           <a:lstStyle/>
           <a:p>
             <a:pPr algn="ctr"/>
+            <a:endParaRPr/>
           </a:p>
         </p:txBody>
       </p:sp>
@@ -3183,7 +3186,7 @@
           <a:noFill/>
         </p:spPr>
         <p:txBody>
-          <a:bodyPr wrap="square" lIns="0" rIns="0" tIns="0" bIns="0" anchor="t">
+          <a:bodyPr wrap="square" lIns="0" tIns="0" rIns="0" bIns="0" anchor="t">
             <a:spAutoFit/>
           </a:bodyPr>
           <a:lstStyle/>
@@ -3222,7 +3225,7 @@
           <a:noFill/>
         </p:spPr>
         <p:txBody>
-          <a:bodyPr wrap="square" lIns="0" rIns="0" tIns="0" bIns="0" anchor="t">
+          <a:bodyPr wrap="square" lIns="0" tIns="0" rIns="0" bIns="0" anchor="t">
             <a:spAutoFit/>
           </a:bodyPr>
           <a:lstStyle/>
@@ -3262,7 +3265,7 @@
           <a:noFill/>
         </p:spPr>
         <p:txBody>
-          <a:bodyPr wrap="square" lIns="0" rIns="0" tIns="0" bIns="0" anchor="t">
+          <a:bodyPr wrap="square" lIns="0" tIns="0" rIns="0" bIns="0" anchor="t">
             <a:spAutoFit/>
           </a:bodyPr>
           <a:lstStyle/>
@@ -3301,7 +3304,7 @@
           <a:noFill/>
         </p:spPr>
         <p:txBody>
-          <a:bodyPr wrap="square" lIns="0" rIns="0" tIns="0" bIns="0" anchor="t">
+          <a:bodyPr wrap="square" lIns="0" tIns="0" rIns="0" bIns="0" anchor="t">
             <a:spAutoFit/>
           </a:bodyPr>
           <a:lstStyle/>
@@ -3332,7 +3335,7 @@
 </file>
 
 <file path=ppt/slides/slide10.xml><?xml version="1.0" encoding="utf-8"?>
-<p:sld xmlns:a="http://schemas.openxmlformats.org/drawingml/2006/main" xmlns:p="http://schemas.openxmlformats.org/presentationml/2006/main" xmlns:r="http://schemas.openxmlformats.org/officeDocument/2006/relationships">
+<p:sld xmlns:a="http://schemas.openxmlformats.org/drawingml/2006/main" xmlns:r="http://schemas.openxmlformats.org/officeDocument/2006/relationships" xmlns:p="http://schemas.openxmlformats.org/presentationml/2006/main">
   <p:cSld>
     <p:spTree>
       <p:nvGrpSpPr>
@@ -3340,7 +3343,14 @@
         <p:cNvGrpSpPr/>
         <p:nvPr/>
       </p:nvGrpSpPr>
-      <p:grpSpPr/>
+      <p:grpSpPr>
+        <a:xfrm>
+          <a:off x="0" y="0"/>
+          <a:ext cx="0" cy="0"/>
+          <a:chOff x="0" y="0"/>
+          <a:chExt cx="0" cy="0"/>
+        </a:xfrm>
+      </p:grpSpPr>
       <p:sp>
         <p:nvSpPr>
           <p:cNvPr id="2" name="Rectangle 1"/>
@@ -3382,6 +3392,7 @@
           <a:lstStyle/>
           <a:p>
             <a:pPr algn="ctr"/>
+            <a:endParaRPr/>
           </a:p>
         </p:txBody>
       </p:sp>
@@ -3402,7 +3413,7 @@
           <a:noFill/>
         </p:spPr>
         <p:txBody>
-          <a:bodyPr wrap="square" lIns="0" rIns="0" tIns="0" bIns="0" anchor="t">
+          <a:bodyPr wrap="square" lIns="0" tIns="0" rIns="0" bIns="0" anchor="t">
             <a:spAutoFit/>
           </a:bodyPr>
           <a:lstStyle/>
@@ -3441,7 +3452,7 @@
           <a:noFill/>
         </p:spPr>
         <p:txBody>
-          <a:bodyPr wrap="square" lIns="0" rIns="0" tIns="0" bIns="0" anchor="t">
+          <a:bodyPr wrap="square" lIns="0" tIns="0" rIns="0" bIns="0" anchor="t">
             <a:spAutoFit/>
           </a:bodyPr>
           <a:lstStyle/>
@@ -3544,6 +3555,7 @@
           <a:lstStyle/>
           <a:p>
             <a:pPr algn="ctr"/>
+            <a:endParaRPr/>
           </a:p>
         </p:txBody>
       </p:sp>
@@ -3564,7 +3576,7 @@
           <a:noFill/>
         </p:spPr>
         <p:txBody>
-          <a:bodyPr wrap="square" lIns="0" rIns="0" tIns="0" bIns="0" anchor="t">
+          <a:bodyPr wrap="square" lIns="0" tIns="0" rIns="0" bIns="0" anchor="t">
             <a:spAutoFit/>
           </a:bodyPr>
           <a:lstStyle/>
@@ -3603,7 +3615,7 @@
           <a:noFill/>
         </p:spPr>
         <p:txBody>
-          <a:bodyPr wrap="square" lIns="0" rIns="0" tIns="0" bIns="0" anchor="t">
+          <a:bodyPr wrap="square" lIns="0" tIns="0" rIns="0" bIns="0" anchor="t">
             <a:spAutoFit/>
           </a:bodyPr>
           <a:lstStyle/>
@@ -3642,7 +3654,7 @@
           <a:noFill/>
         </p:spPr>
         <p:txBody>
-          <a:bodyPr wrap="square" lIns="0" rIns="0" tIns="0" bIns="0" anchor="t">
+          <a:bodyPr wrap="square" lIns="0" tIns="0" rIns="0" bIns="0" anchor="t">
             <a:spAutoFit/>
           </a:bodyPr>
           <a:lstStyle/>
@@ -3705,6 +3717,7 @@
           <a:lstStyle/>
           <a:p>
             <a:pPr algn="ctr"/>
+            <a:endParaRPr/>
           </a:p>
         </p:txBody>
       </p:sp>
@@ -3753,6 +3766,7 @@
           <a:lstStyle/>
           <a:p>
             <a:pPr algn="ctr"/>
+            <a:endParaRPr/>
           </a:p>
         </p:txBody>
       </p:sp>
@@ -3773,7 +3787,7 @@
           <a:noFill/>
         </p:spPr>
         <p:txBody>
-          <a:bodyPr wrap="square" lIns="0" rIns="0" tIns="0" bIns="0" anchor="t">
+          <a:bodyPr wrap="square" lIns="0" tIns="0" rIns="0" bIns="0" anchor="t">
             <a:spAutoFit/>
           </a:bodyPr>
           <a:lstStyle/>
@@ -3812,7 +3826,7 @@
           <a:noFill/>
         </p:spPr>
         <p:txBody>
-          <a:bodyPr wrap="square" lIns="0" rIns="0" tIns="0" bIns="0" anchor="t">
+          <a:bodyPr wrap="square" lIns="0" tIns="0" rIns="0" bIns="0" anchor="t">
             <a:spAutoFit/>
           </a:bodyPr>
           <a:lstStyle/>
@@ -3851,7 +3865,7 @@
           <a:noFill/>
         </p:spPr>
         <p:txBody>
-          <a:bodyPr wrap="square" lIns="0" rIns="0" tIns="0" bIns="0" anchor="t">
+          <a:bodyPr wrap="square" lIns="0" tIns="0" rIns="0" bIns="0" anchor="t">
             <a:spAutoFit/>
           </a:bodyPr>
           <a:lstStyle/>
@@ -3914,6 +3928,7 @@
           <a:lstStyle/>
           <a:p>
             <a:pPr algn="ctr"/>
+            <a:endParaRPr/>
           </a:p>
         </p:txBody>
       </p:sp>
@@ -3962,6 +3977,7 @@
           <a:lstStyle/>
           <a:p>
             <a:pPr algn="ctr"/>
+            <a:endParaRPr/>
           </a:p>
         </p:txBody>
       </p:sp>
@@ -3982,7 +3998,7 @@
           <a:noFill/>
         </p:spPr>
         <p:txBody>
-          <a:bodyPr wrap="square" lIns="0" rIns="0" tIns="0" bIns="0" anchor="t">
+          <a:bodyPr wrap="square" lIns="0" tIns="0" rIns="0" bIns="0" anchor="t">
             <a:spAutoFit/>
           </a:bodyPr>
           <a:lstStyle/>
@@ -4021,7 +4037,7 @@
           <a:noFill/>
         </p:spPr>
         <p:txBody>
-          <a:bodyPr wrap="square" lIns="0" rIns="0" tIns="0" bIns="0" anchor="t">
+          <a:bodyPr wrap="square" lIns="0" tIns="0" rIns="0" bIns="0" anchor="t">
             <a:spAutoFit/>
           </a:bodyPr>
           <a:lstStyle/>
@@ -4060,7 +4076,7 @@
           <a:noFill/>
         </p:spPr>
         <p:txBody>
-          <a:bodyPr wrap="square" lIns="0" rIns="0" tIns="0" bIns="0" anchor="t">
+          <a:bodyPr wrap="square" lIns="0" tIns="0" rIns="0" bIns="0" anchor="t">
             <a:spAutoFit/>
           </a:bodyPr>
           <a:lstStyle/>
@@ -4123,6 +4139,7 @@
           <a:lstStyle/>
           <a:p>
             <a:pPr algn="ctr"/>
+            <a:endParaRPr/>
           </a:p>
         </p:txBody>
       </p:sp>
@@ -4143,7 +4160,7 @@
           <a:noFill/>
         </p:spPr>
         <p:txBody>
-          <a:bodyPr wrap="square" lIns="0" rIns="0" tIns="0" bIns="0" anchor="t">
+          <a:bodyPr wrap="square" lIns="0" tIns="0" rIns="0" bIns="0" anchor="t">
             <a:spAutoFit/>
           </a:bodyPr>
           <a:lstStyle/>
@@ -4174,7 +4191,7 @@
 </file>
 
 <file path=ppt/slides/slide11.xml><?xml version="1.0" encoding="utf-8"?>
-<p:sld xmlns:a="http://schemas.openxmlformats.org/drawingml/2006/main" xmlns:p="http://schemas.openxmlformats.org/presentationml/2006/main" xmlns:r="http://schemas.openxmlformats.org/officeDocument/2006/relationships">
+<p:sld xmlns:a="http://schemas.openxmlformats.org/drawingml/2006/main" xmlns:r="http://schemas.openxmlformats.org/officeDocument/2006/relationships" xmlns:p="http://schemas.openxmlformats.org/presentationml/2006/main">
   <p:cSld>
     <p:spTree>
       <p:nvGrpSpPr>
@@ -4182,7 +4199,14 @@
         <p:cNvGrpSpPr/>
         <p:nvPr/>
       </p:nvGrpSpPr>
-      <p:grpSpPr/>
+      <p:grpSpPr>
+        <a:xfrm>
+          <a:off x="0" y="0"/>
+          <a:ext cx="0" cy="0"/>
+          <a:chOff x="0" y="0"/>
+          <a:chExt cx="0" cy="0"/>
+        </a:xfrm>
+      </p:grpSpPr>
       <p:sp>
         <p:nvSpPr>
           <p:cNvPr id="2" name="Rectangle 1"/>
@@ -4224,6 +4248,7 @@
           <a:lstStyle/>
           <a:p>
             <a:pPr algn="ctr"/>
+            <a:endParaRPr/>
           </a:p>
         </p:txBody>
       </p:sp>
@@ -4268,7 +4293,7 @@
           <a:noFill/>
         </p:spPr>
         <p:txBody>
-          <a:bodyPr wrap="square" lIns="0" rIns="0" tIns="0" bIns="0" anchor="t">
+          <a:bodyPr wrap="square" lIns="0" tIns="0" rIns="0" bIns="0" anchor="t">
             <a:spAutoFit/>
           </a:bodyPr>
           <a:lstStyle/>
@@ -4307,7 +4332,7 @@
           <a:noFill/>
         </p:spPr>
         <p:txBody>
-          <a:bodyPr wrap="square" lIns="0" rIns="0" tIns="0" bIns="0" anchor="t">
+          <a:bodyPr wrap="square" lIns="0" tIns="0" rIns="0" bIns="0" anchor="t">
             <a:spAutoFit/>
           </a:bodyPr>
           <a:lstStyle/>
@@ -4318,7 +4343,7 @@
               </a:lnSpc>
             </a:pPr>
             <a:r>
-              <a:rPr sz="1300" b="1">
+              <a:rPr sz="1300" b="1" dirty="0">
                 <a:solidFill>
                   <a:srgbClr val="7A726A"/>
                 </a:solidFill>
@@ -4338,7 +4363,7 @@
 </file>
 
 <file path=ppt/slides/slide2.xml><?xml version="1.0" encoding="utf-8"?>
-<p:sld xmlns:a="http://schemas.openxmlformats.org/drawingml/2006/main" xmlns:p="http://schemas.openxmlformats.org/presentationml/2006/main" xmlns:r="http://schemas.openxmlformats.org/officeDocument/2006/relationships">
+<p:sld xmlns:a="http://schemas.openxmlformats.org/drawingml/2006/main" xmlns:r="http://schemas.openxmlformats.org/officeDocument/2006/relationships" xmlns:p="http://schemas.openxmlformats.org/presentationml/2006/main">
   <p:cSld>
     <p:spTree>
       <p:nvGrpSpPr>
@@ -4346,7 +4371,14 @@
         <p:cNvGrpSpPr/>
         <p:nvPr/>
       </p:nvGrpSpPr>
-      <p:grpSpPr/>
+      <p:grpSpPr>
+        <a:xfrm>
+          <a:off x="0" y="0"/>
+          <a:ext cx="0" cy="0"/>
+          <a:chOff x="0" y="0"/>
+          <a:chExt cx="0" cy="0"/>
+        </a:xfrm>
+      </p:grpSpPr>
       <p:sp>
         <p:nvSpPr>
           <p:cNvPr id="2" name="Rectangle 1"/>
@@ -4355,8 +4387,8 @@
         </p:nvSpPr>
         <p:spPr>
           <a:xfrm>
-            <a:off x="0" y="0"/>
-            <a:ext cx="12191695" cy="6858000"/>
+            <a:off x="0" y="-374904"/>
+            <a:ext cx="12191695" cy="7309104"/>
           </a:xfrm>
           <a:prstGeom prst="rect">
             <a:avLst/>
@@ -4388,6 +4420,7 @@
           <a:lstStyle/>
           <a:p>
             <a:pPr algn="ctr"/>
+            <a:endParaRPr/>
           </a:p>
         </p:txBody>
       </p:sp>
@@ -4399,7 +4432,7 @@
         </p:nvSpPr>
         <p:spPr>
           <a:xfrm>
-            <a:off x="777240" y="658368"/>
+            <a:off x="777240" y="330539"/>
             <a:ext cx="10607040" cy="1005840"/>
           </a:xfrm>
           <a:prstGeom prst="rect">
@@ -4408,7 +4441,7 @@
           <a:noFill/>
         </p:spPr>
         <p:txBody>
-          <a:bodyPr wrap="square" lIns="0" rIns="0" tIns="0" bIns="0" anchor="t">
+          <a:bodyPr wrap="square" lIns="0" tIns="0" rIns="0" bIns="0" anchor="t">
             <a:spAutoFit/>
           </a:bodyPr>
           <a:lstStyle/>
@@ -4419,7 +4452,7 @@
               </a:lnSpc>
             </a:pPr>
             <a:r>
-              <a:rPr sz="4000" b="1">
+              <a:rPr sz="4000" b="1" dirty="0">
                 <a:solidFill>
                   <a:srgbClr val="26221E"/>
                 </a:solidFill>
@@ -4438,8 +4471,8 @@
         </p:nvSpPr>
         <p:spPr>
           <a:xfrm>
-            <a:off x="777240" y="2084832"/>
-            <a:ext cx="365760" cy="365760"/>
+            <a:off x="777240" y="1709927"/>
+            <a:ext cx="365760" cy="389819"/>
           </a:xfrm>
           <a:prstGeom prst="roundRect">
             <a:avLst>
@@ -4475,6 +4508,7 @@
           <a:lstStyle/>
           <a:p>
             <a:pPr algn="ctr"/>
+            <a:endParaRPr/>
           </a:p>
         </p:txBody>
       </p:sp>
@@ -4486,7 +4520,7 @@
         </p:nvSpPr>
         <p:spPr>
           <a:xfrm>
-            <a:off x="777240" y="2084832"/>
+            <a:off x="777240" y="1709928"/>
             <a:ext cx="365760" cy="365760"/>
           </a:xfrm>
           <a:prstGeom prst="rect">
@@ -4495,7 +4529,7 @@
           <a:noFill/>
         </p:spPr>
         <p:txBody>
-          <a:bodyPr wrap="square" lIns="0" rIns="0" tIns="0" bIns="0" anchor="ctr">
+          <a:bodyPr wrap="square" lIns="0" tIns="0" rIns="0" bIns="0" anchor="ctr">
             <a:spAutoFit/>
           </a:bodyPr>
           <a:lstStyle/>
@@ -4520,12 +4554,14 @@
       <p:cxnSp>
         <p:nvCxnSpPr>
           <p:cNvPr id="6" name="Connector 5"/>
-          <p:cNvCxnSpPr/>
+          <p:cNvCxnSpPr>
+            <a:cxnSpLocks/>
+          </p:cNvCxnSpPr>
           <p:nvPr/>
         </p:nvCxnSpPr>
         <p:spPr>
           <a:xfrm>
-            <a:off x="1344168" y="2267712"/>
+            <a:off x="1344168" y="1892808"/>
             <a:ext cx="1124712" cy="0"/>
           </a:xfrm>
           <a:prstGeom prst="line">
@@ -4561,7 +4597,7 @@
         </p:nvSpPr>
         <p:spPr>
           <a:xfrm>
-            <a:off x="2697480" y="1965960"/>
+            <a:off x="2697480" y="1591056"/>
             <a:ext cx="5486400" cy="603504"/>
           </a:xfrm>
           <a:prstGeom prst="rect">
@@ -4570,7 +4606,7 @@
           <a:noFill/>
         </p:spPr>
         <p:txBody>
-          <a:bodyPr wrap="square" lIns="0" rIns="0" tIns="0" bIns="0" anchor="ctr">
+          <a:bodyPr wrap="square" lIns="0" tIns="0" rIns="0" bIns="0" anchor="ctr">
             <a:spAutoFit/>
           </a:bodyPr>
           <a:lstStyle/>
@@ -4581,7 +4617,7 @@
               </a:lnSpc>
             </a:pPr>
             <a:r>
-              <a:rPr sz="1550" b="1">
+              <a:rPr sz="1550" b="1" dirty="0">
                 <a:solidFill>
                   <a:srgbClr val="26221E"/>
                 </a:solidFill>
@@ -4600,7 +4636,7 @@
         </p:nvSpPr>
         <p:spPr>
           <a:xfrm>
-            <a:off x="8138160" y="1965960"/>
+            <a:off x="8138160" y="1591056"/>
             <a:ext cx="3657600" cy="603504"/>
           </a:xfrm>
           <a:prstGeom prst="rect">
@@ -4609,7 +4645,7 @@
           <a:noFill/>
         </p:spPr>
         <p:txBody>
-          <a:bodyPr wrap="square" lIns="0" rIns="0" tIns="0" bIns="0" anchor="ctr">
+          <a:bodyPr wrap="square" lIns="0" tIns="0" rIns="0" bIns="0" anchor="ctr">
             <a:spAutoFit/>
           </a:bodyPr>
           <a:lstStyle/>
@@ -4639,8 +4675,8 @@
         </p:nvSpPr>
         <p:spPr>
           <a:xfrm>
-            <a:off x="777240" y="2761488"/>
-            <a:ext cx="365760" cy="365760"/>
+            <a:off x="777240" y="2386583"/>
+            <a:ext cx="365760" cy="389819"/>
           </a:xfrm>
           <a:prstGeom prst="roundRect">
             <a:avLst>
@@ -4676,6 +4712,7 @@
           <a:lstStyle/>
           <a:p>
             <a:pPr algn="ctr"/>
+            <a:endParaRPr/>
           </a:p>
         </p:txBody>
       </p:sp>
@@ -4687,7 +4724,7 @@
         </p:nvSpPr>
         <p:spPr>
           <a:xfrm>
-            <a:off x="777240" y="2761488"/>
+            <a:off x="777240" y="2386584"/>
             <a:ext cx="365760" cy="365760"/>
           </a:xfrm>
           <a:prstGeom prst="rect">
@@ -4696,7 +4733,7 @@
           <a:noFill/>
         </p:spPr>
         <p:txBody>
-          <a:bodyPr wrap="square" lIns="0" rIns="0" tIns="0" bIns="0" anchor="ctr">
+          <a:bodyPr wrap="square" lIns="0" tIns="0" rIns="0" bIns="0" anchor="ctr">
             <a:spAutoFit/>
           </a:bodyPr>
           <a:lstStyle/>
@@ -4721,12 +4758,14 @@
       <p:cxnSp>
         <p:nvCxnSpPr>
           <p:cNvPr id="11" name="Connector 10"/>
-          <p:cNvCxnSpPr/>
+          <p:cNvCxnSpPr>
+            <a:cxnSpLocks/>
+          </p:cNvCxnSpPr>
           <p:nvPr/>
         </p:nvCxnSpPr>
         <p:spPr>
           <a:xfrm>
-            <a:off x="1344168" y="2944368"/>
+            <a:off x="1344168" y="2569464"/>
             <a:ext cx="1124712" cy="0"/>
           </a:xfrm>
           <a:prstGeom prst="line">
@@ -4762,7 +4801,7 @@
         </p:nvSpPr>
         <p:spPr>
           <a:xfrm>
-            <a:off x="2697480" y="2642616"/>
+            <a:off x="2697480" y="2267712"/>
             <a:ext cx="5486400" cy="603504"/>
           </a:xfrm>
           <a:prstGeom prst="rect">
@@ -4771,7 +4810,7 @@
           <a:noFill/>
         </p:spPr>
         <p:txBody>
-          <a:bodyPr wrap="square" lIns="0" rIns="0" tIns="0" bIns="0" anchor="ctr">
+          <a:bodyPr wrap="square" lIns="0" tIns="0" rIns="0" bIns="0" anchor="ctr">
             <a:spAutoFit/>
           </a:bodyPr>
           <a:lstStyle/>
@@ -4801,7 +4840,7 @@
         </p:nvSpPr>
         <p:spPr>
           <a:xfrm>
-            <a:off x="8138160" y="2642616"/>
+            <a:off x="8138160" y="2267712"/>
             <a:ext cx="3657600" cy="603504"/>
           </a:xfrm>
           <a:prstGeom prst="rect">
@@ -4810,7 +4849,7 @@
           <a:noFill/>
         </p:spPr>
         <p:txBody>
-          <a:bodyPr wrap="square" lIns="0" rIns="0" tIns="0" bIns="0" anchor="ctr">
+          <a:bodyPr wrap="square" lIns="0" tIns="0" rIns="0" bIns="0" anchor="ctr">
             <a:spAutoFit/>
           </a:bodyPr>
           <a:lstStyle/>
@@ -4840,8 +4879,8 @@
         </p:nvSpPr>
         <p:spPr>
           <a:xfrm>
-            <a:off x="777240" y="3438144"/>
-            <a:ext cx="365760" cy="365760"/>
+            <a:off x="777240" y="3063239"/>
+            <a:ext cx="365760" cy="389819"/>
           </a:xfrm>
           <a:prstGeom prst="roundRect">
             <a:avLst>
@@ -4877,6 +4916,7 @@
           <a:lstStyle/>
           <a:p>
             <a:pPr algn="ctr"/>
+            <a:endParaRPr/>
           </a:p>
         </p:txBody>
       </p:sp>
@@ -4888,7 +4928,7 @@
         </p:nvSpPr>
         <p:spPr>
           <a:xfrm>
-            <a:off x="777240" y="3438144"/>
+            <a:off x="777240" y="3063240"/>
             <a:ext cx="365760" cy="365760"/>
           </a:xfrm>
           <a:prstGeom prst="rect">
@@ -4897,7 +4937,7 @@
           <a:noFill/>
         </p:spPr>
         <p:txBody>
-          <a:bodyPr wrap="square" lIns="0" rIns="0" tIns="0" bIns="0" anchor="ctr">
+          <a:bodyPr wrap="square" lIns="0" tIns="0" rIns="0" bIns="0" anchor="ctr">
             <a:spAutoFit/>
           </a:bodyPr>
           <a:lstStyle/>
@@ -4922,12 +4962,14 @@
       <p:cxnSp>
         <p:nvCxnSpPr>
           <p:cNvPr id="16" name="Connector 15"/>
-          <p:cNvCxnSpPr/>
+          <p:cNvCxnSpPr>
+            <a:cxnSpLocks/>
+          </p:cNvCxnSpPr>
           <p:nvPr/>
         </p:nvCxnSpPr>
         <p:spPr>
           <a:xfrm>
-            <a:off x="1344168" y="3621024"/>
+            <a:off x="1344168" y="3246120"/>
             <a:ext cx="1124712" cy="0"/>
           </a:xfrm>
           <a:prstGeom prst="line">
@@ -4963,7 +5005,7 @@
         </p:nvSpPr>
         <p:spPr>
           <a:xfrm>
-            <a:off x="2697480" y="3319272"/>
+            <a:off x="2697480" y="2944368"/>
             <a:ext cx="5486400" cy="603504"/>
           </a:xfrm>
           <a:prstGeom prst="rect">
@@ -4972,7 +5014,7 @@
           <a:noFill/>
         </p:spPr>
         <p:txBody>
-          <a:bodyPr wrap="square" lIns="0" rIns="0" tIns="0" bIns="0" anchor="ctr">
+          <a:bodyPr wrap="square" lIns="0" tIns="0" rIns="0" bIns="0" anchor="ctr">
             <a:spAutoFit/>
           </a:bodyPr>
           <a:lstStyle/>
@@ -5002,7 +5044,7 @@
         </p:nvSpPr>
         <p:spPr>
           <a:xfrm>
-            <a:off x="8138160" y="3319272"/>
+            <a:off x="8138160" y="2944368"/>
             <a:ext cx="3657600" cy="603504"/>
           </a:xfrm>
           <a:prstGeom prst="rect">
@@ -5011,7 +5053,7 @@
           <a:noFill/>
         </p:spPr>
         <p:txBody>
-          <a:bodyPr wrap="square" lIns="0" rIns="0" tIns="0" bIns="0" anchor="ctr">
+          <a:bodyPr wrap="square" lIns="0" tIns="0" rIns="0" bIns="0" anchor="ctr">
             <a:spAutoFit/>
           </a:bodyPr>
           <a:lstStyle/>
@@ -5041,8 +5083,8 @@
         </p:nvSpPr>
         <p:spPr>
           <a:xfrm>
-            <a:off x="777240" y="4114800"/>
-            <a:ext cx="365760" cy="365760"/>
+            <a:off x="777240" y="3739895"/>
+            <a:ext cx="365760" cy="389819"/>
           </a:xfrm>
           <a:prstGeom prst="roundRect">
             <a:avLst>
@@ -5078,6 +5120,7 @@
           <a:lstStyle/>
           <a:p>
             <a:pPr algn="ctr"/>
+            <a:endParaRPr/>
           </a:p>
         </p:txBody>
       </p:sp>
@@ -5089,7 +5132,7 @@
         </p:nvSpPr>
         <p:spPr>
           <a:xfrm>
-            <a:off x="777240" y="4114800"/>
+            <a:off x="777240" y="3739896"/>
             <a:ext cx="365760" cy="365760"/>
           </a:xfrm>
           <a:prstGeom prst="rect">
@@ -5098,7 +5141,7 @@
           <a:noFill/>
         </p:spPr>
         <p:txBody>
-          <a:bodyPr wrap="square" lIns="0" rIns="0" tIns="0" bIns="0" anchor="ctr">
+          <a:bodyPr wrap="square" lIns="0" tIns="0" rIns="0" bIns="0" anchor="ctr">
             <a:spAutoFit/>
           </a:bodyPr>
           <a:lstStyle/>
@@ -5123,12 +5166,14 @@
       <p:cxnSp>
         <p:nvCxnSpPr>
           <p:cNvPr id="21" name="Connector 20"/>
-          <p:cNvCxnSpPr/>
+          <p:cNvCxnSpPr>
+            <a:cxnSpLocks/>
+          </p:cNvCxnSpPr>
           <p:nvPr/>
         </p:nvCxnSpPr>
         <p:spPr>
           <a:xfrm>
-            <a:off x="1344168" y="4297680"/>
+            <a:off x="1344168" y="3922776"/>
             <a:ext cx="1124712" cy="0"/>
           </a:xfrm>
           <a:prstGeom prst="line">
@@ -5164,7 +5209,7 @@
         </p:nvSpPr>
         <p:spPr>
           <a:xfrm>
-            <a:off x="2697480" y="3995928"/>
+            <a:off x="2697480" y="3621024"/>
             <a:ext cx="5486400" cy="603504"/>
           </a:xfrm>
           <a:prstGeom prst="rect">
@@ -5173,7 +5218,7 @@
           <a:noFill/>
         </p:spPr>
         <p:txBody>
-          <a:bodyPr wrap="square" lIns="0" rIns="0" tIns="0" bIns="0" anchor="ctr">
+          <a:bodyPr wrap="square" lIns="0" tIns="0" rIns="0" bIns="0" anchor="ctr">
             <a:spAutoFit/>
           </a:bodyPr>
           <a:lstStyle/>
@@ -5203,7 +5248,7 @@
         </p:nvSpPr>
         <p:spPr>
           <a:xfrm>
-            <a:off x="8138160" y="3995928"/>
+            <a:off x="8138160" y="3621024"/>
             <a:ext cx="3657600" cy="603504"/>
           </a:xfrm>
           <a:prstGeom prst="rect">
@@ -5212,7 +5257,7 @@
           <a:noFill/>
         </p:spPr>
         <p:txBody>
-          <a:bodyPr wrap="square" lIns="0" rIns="0" tIns="0" bIns="0" anchor="ctr">
+          <a:bodyPr wrap="square" lIns="0" tIns="0" rIns="0" bIns="0" anchor="ctr">
             <a:spAutoFit/>
           </a:bodyPr>
           <a:lstStyle/>
@@ -5242,8 +5287,8 @@
         </p:nvSpPr>
         <p:spPr>
           <a:xfrm>
-            <a:off x="777240" y="4791456"/>
-            <a:ext cx="365760" cy="365760"/>
+            <a:off x="777240" y="4416551"/>
+            <a:ext cx="365760" cy="389819"/>
           </a:xfrm>
           <a:prstGeom prst="roundRect">
             <a:avLst>
@@ -5279,6 +5324,7 @@
           <a:lstStyle/>
           <a:p>
             <a:pPr algn="ctr"/>
+            <a:endParaRPr/>
           </a:p>
         </p:txBody>
       </p:sp>
@@ -5290,7 +5336,7 @@
         </p:nvSpPr>
         <p:spPr>
           <a:xfrm>
-            <a:off x="777240" y="4791456"/>
+            <a:off x="777240" y="4416552"/>
             <a:ext cx="365760" cy="365760"/>
           </a:xfrm>
           <a:prstGeom prst="rect">
@@ -5299,7 +5345,7 @@
           <a:noFill/>
         </p:spPr>
         <p:txBody>
-          <a:bodyPr wrap="square" lIns="0" rIns="0" tIns="0" bIns="0" anchor="ctr">
+          <a:bodyPr wrap="square" lIns="0" tIns="0" rIns="0" bIns="0" anchor="ctr">
             <a:spAutoFit/>
           </a:bodyPr>
           <a:lstStyle/>
@@ -5324,12 +5370,14 @@
       <p:cxnSp>
         <p:nvCxnSpPr>
           <p:cNvPr id="26" name="Connector 25"/>
-          <p:cNvCxnSpPr/>
+          <p:cNvCxnSpPr>
+            <a:cxnSpLocks/>
+          </p:cNvCxnSpPr>
           <p:nvPr/>
         </p:nvCxnSpPr>
         <p:spPr>
           <a:xfrm>
-            <a:off x="1344168" y="4974336"/>
+            <a:off x="1344168" y="4599432"/>
             <a:ext cx="1124712" cy="0"/>
           </a:xfrm>
           <a:prstGeom prst="line">
@@ -5365,7 +5413,7 @@
         </p:nvSpPr>
         <p:spPr>
           <a:xfrm>
-            <a:off x="2697480" y="4672584"/>
+            <a:off x="2697480" y="4297680"/>
             <a:ext cx="5486400" cy="603504"/>
           </a:xfrm>
           <a:prstGeom prst="rect">
@@ -5374,7 +5422,7 @@
           <a:noFill/>
         </p:spPr>
         <p:txBody>
-          <a:bodyPr wrap="square" lIns="0" rIns="0" tIns="0" bIns="0" anchor="ctr">
+          <a:bodyPr wrap="square" lIns="0" tIns="0" rIns="0" bIns="0" anchor="ctr">
             <a:spAutoFit/>
           </a:bodyPr>
           <a:lstStyle/>
@@ -5404,7 +5452,7 @@
         </p:nvSpPr>
         <p:spPr>
           <a:xfrm>
-            <a:off x="8138160" y="4672584"/>
+            <a:off x="8138160" y="4297680"/>
             <a:ext cx="3657600" cy="603504"/>
           </a:xfrm>
           <a:prstGeom prst="rect">
@@ -5413,7 +5461,7 @@
           <a:noFill/>
         </p:spPr>
         <p:txBody>
-          <a:bodyPr wrap="square" lIns="0" rIns="0" tIns="0" bIns="0" anchor="ctr">
+          <a:bodyPr wrap="square" lIns="0" tIns="0" rIns="0" bIns="0" anchor="ctr">
             <a:spAutoFit/>
           </a:bodyPr>
           <a:lstStyle/>
@@ -5443,8 +5491,8 @@
         </p:nvSpPr>
         <p:spPr>
           <a:xfrm>
-            <a:off x="777240" y="5468112"/>
-            <a:ext cx="365760" cy="365760"/>
+            <a:off x="777240" y="5093207"/>
+            <a:ext cx="365760" cy="389819"/>
           </a:xfrm>
           <a:prstGeom prst="roundRect">
             <a:avLst>
@@ -5480,6 +5528,7 @@
           <a:lstStyle/>
           <a:p>
             <a:pPr algn="ctr"/>
+            <a:endParaRPr/>
           </a:p>
         </p:txBody>
       </p:sp>
@@ -5491,7 +5540,7 @@
         </p:nvSpPr>
         <p:spPr>
           <a:xfrm>
-            <a:off x="777240" y="5468112"/>
+            <a:off x="777240" y="5093208"/>
             <a:ext cx="365760" cy="365760"/>
           </a:xfrm>
           <a:prstGeom prst="rect">
@@ -5500,7 +5549,7 @@
           <a:noFill/>
         </p:spPr>
         <p:txBody>
-          <a:bodyPr wrap="square" lIns="0" rIns="0" tIns="0" bIns="0" anchor="ctr">
+          <a:bodyPr wrap="square" lIns="0" tIns="0" rIns="0" bIns="0" anchor="ctr">
             <a:spAutoFit/>
           </a:bodyPr>
           <a:lstStyle/>
@@ -5525,12 +5574,14 @@
       <p:cxnSp>
         <p:nvCxnSpPr>
           <p:cNvPr id="31" name="Connector 30"/>
-          <p:cNvCxnSpPr/>
+          <p:cNvCxnSpPr>
+            <a:cxnSpLocks/>
+          </p:cNvCxnSpPr>
           <p:nvPr/>
         </p:nvCxnSpPr>
         <p:spPr>
           <a:xfrm>
-            <a:off x="1344168" y="5650992"/>
+            <a:off x="1344168" y="5276088"/>
             <a:ext cx="1124712" cy="0"/>
           </a:xfrm>
           <a:prstGeom prst="line">
@@ -5566,7 +5617,7 @@
         </p:nvSpPr>
         <p:spPr>
           <a:xfrm>
-            <a:off x="2697480" y="5349240"/>
+            <a:off x="2697480" y="4974336"/>
             <a:ext cx="5486400" cy="603504"/>
           </a:xfrm>
           <a:prstGeom prst="rect">
@@ -5575,7 +5626,7 @@
           <a:noFill/>
         </p:spPr>
         <p:txBody>
-          <a:bodyPr wrap="square" lIns="0" rIns="0" tIns="0" bIns="0" anchor="ctr">
+          <a:bodyPr wrap="square" lIns="0" tIns="0" rIns="0" bIns="0" anchor="ctr">
             <a:spAutoFit/>
           </a:bodyPr>
           <a:lstStyle/>
@@ -5605,7 +5656,7 @@
         </p:nvSpPr>
         <p:spPr>
           <a:xfrm>
-            <a:off x="8138160" y="5349240"/>
+            <a:off x="8138160" y="4974336"/>
             <a:ext cx="3657600" cy="603504"/>
           </a:xfrm>
           <a:prstGeom prst="rect">
@@ -5614,7 +5665,7 @@
           <a:noFill/>
         </p:spPr>
         <p:txBody>
-          <a:bodyPr wrap="square" lIns="0" rIns="0" tIns="0" bIns="0" anchor="ctr">
+          <a:bodyPr wrap="square" lIns="0" tIns="0" rIns="0" bIns="0" anchor="ctr">
             <a:spAutoFit/>
           </a:bodyPr>
           <a:lstStyle/>
@@ -5644,8 +5695,8 @@
         </p:nvSpPr>
         <p:spPr>
           <a:xfrm>
-            <a:off x="777240" y="6144768"/>
-            <a:ext cx="365760" cy="365760"/>
+            <a:off x="777240" y="5769863"/>
+            <a:ext cx="365760" cy="389819"/>
           </a:xfrm>
           <a:prstGeom prst="roundRect">
             <a:avLst>
@@ -5681,6 +5732,7 @@
           <a:lstStyle/>
           <a:p>
             <a:pPr algn="ctr"/>
+            <a:endParaRPr/>
           </a:p>
         </p:txBody>
       </p:sp>
@@ -5692,7 +5744,7 @@
         </p:nvSpPr>
         <p:spPr>
           <a:xfrm>
-            <a:off x="777240" y="6144768"/>
+            <a:off x="777240" y="5769864"/>
             <a:ext cx="365760" cy="365760"/>
           </a:xfrm>
           <a:prstGeom prst="rect">
@@ -5701,7 +5753,7 @@
           <a:noFill/>
         </p:spPr>
         <p:txBody>
-          <a:bodyPr wrap="square" lIns="0" rIns="0" tIns="0" bIns="0" anchor="ctr">
+          <a:bodyPr wrap="square" lIns="0" tIns="0" rIns="0" bIns="0" anchor="ctr">
             <a:spAutoFit/>
           </a:bodyPr>
           <a:lstStyle/>
@@ -5726,12 +5778,14 @@
       <p:cxnSp>
         <p:nvCxnSpPr>
           <p:cNvPr id="36" name="Connector 35"/>
-          <p:cNvCxnSpPr/>
+          <p:cNvCxnSpPr>
+            <a:cxnSpLocks/>
+          </p:cNvCxnSpPr>
           <p:nvPr/>
         </p:nvCxnSpPr>
         <p:spPr>
           <a:xfrm>
-            <a:off x="1344168" y="6327648"/>
+            <a:off x="1344168" y="5952744"/>
             <a:ext cx="1124712" cy="0"/>
           </a:xfrm>
           <a:prstGeom prst="line">
@@ -5767,7 +5821,7 @@
         </p:nvSpPr>
         <p:spPr>
           <a:xfrm>
-            <a:off x="2697480" y="6025896"/>
+            <a:off x="2697480" y="5650992"/>
             <a:ext cx="5486400" cy="603504"/>
           </a:xfrm>
           <a:prstGeom prst="rect">
@@ -5776,7 +5830,7 @@
           <a:noFill/>
         </p:spPr>
         <p:txBody>
-          <a:bodyPr wrap="square" lIns="0" rIns="0" tIns="0" bIns="0" anchor="ctr">
+          <a:bodyPr wrap="square" lIns="0" tIns="0" rIns="0" bIns="0" anchor="ctr">
             <a:spAutoFit/>
           </a:bodyPr>
           <a:lstStyle/>
@@ -5806,7 +5860,7 @@
         </p:nvSpPr>
         <p:spPr>
           <a:xfrm>
-            <a:off x="8138160" y="6025896"/>
+            <a:off x="8138160" y="5650992"/>
             <a:ext cx="3657600" cy="603504"/>
           </a:xfrm>
           <a:prstGeom prst="rect">
@@ -5815,7 +5869,7 @@
           <a:noFill/>
         </p:spPr>
         <p:txBody>
-          <a:bodyPr wrap="square" lIns="0" rIns="0" tIns="0" bIns="0" anchor="ctr">
+          <a:bodyPr wrap="square" lIns="0" tIns="0" rIns="0" bIns="0" anchor="ctr">
             <a:spAutoFit/>
           </a:bodyPr>
           <a:lstStyle/>
@@ -5846,7 +5900,7 @@
 </file>
 
 <file path=ppt/slides/slide3.xml><?xml version="1.0" encoding="utf-8"?>
-<p:sld xmlns:a="http://schemas.openxmlformats.org/drawingml/2006/main" xmlns:p="http://schemas.openxmlformats.org/presentationml/2006/main" xmlns:r="http://schemas.openxmlformats.org/officeDocument/2006/relationships">
+<p:sld xmlns:a="http://schemas.openxmlformats.org/drawingml/2006/main" xmlns:r="http://schemas.openxmlformats.org/officeDocument/2006/relationships" xmlns:p="http://schemas.openxmlformats.org/presentationml/2006/main">
   <p:cSld>
     <p:spTree>
       <p:nvGrpSpPr>
@@ -5854,7 +5908,14 @@
         <p:cNvGrpSpPr/>
         <p:nvPr/>
       </p:nvGrpSpPr>
-      <p:grpSpPr/>
+      <p:grpSpPr>
+        <a:xfrm>
+          <a:off x="0" y="0"/>
+          <a:ext cx="0" cy="0"/>
+          <a:chOff x="0" y="0"/>
+          <a:chExt cx="0" cy="0"/>
+        </a:xfrm>
+      </p:grpSpPr>
       <p:sp>
         <p:nvSpPr>
           <p:cNvPr id="2" name="Rectangle 1"/>
@@ -5896,6 +5957,7 @@
           <a:lstStyle/>
           <a:p>
             <a:pPr algn="ctr"/>
+            <a:endParaRPr/>
           </a:p>
         </p:txBody>
       </p:sp>
@@ -5916,7 +5978,7 @@
           <a:noFill/>
         </p:spPr>
         <p:txBody>
-          <a:bodyPr wrap="square" lIns="0" rIns="0" tIns="0" bIns="0" anchor="t">
+          <a:bodyPr wrap="square" lIns="0" tIns="0" rIns="0" bIns="0" anchor="t">
             <a:spAutoFit/>
           </a:bodyPr>
           <a:lstStyle/>
@@ -5955,7 +6017,7 @@
           <a:noFill/>
         </p:spPr>
         <p:txBody>
-          <a:bodyPr wrap="square" lIns="0" rIns="0" tIns="0" bIns="0" anchor="t">
+          <a:bodyPr wrap="square" lIns="0" tIns="0" rIns="0" bIns="0" anchor="t">
             <a:spAutoFit/>
           </a:bodyPr>
           <a:lstStyle/>
@@ -5994,7 +6056,7 @@
           <a:noFill/>
         </p:spPr>
         <p:txBody>
-          <a:bodyPr wrap="square" lIns="0" rIns="0" tIns="0" bIns="0" anchor="t">
+          <a:bodyPr wrap="square" lIns="0" tIns="0" rIns="0" bIns="0" anchor="t">
             <a:spAutoFit/>
           </a:bodyPr>
           <a:lstStyle/>
@@ -6061,6 +6123,7 @@
           <a:lstStyle/>
           <a:p>
             <a:pPr algn="ctr"/>
+            <a:endParaRPr/>
           </a:p>
         </p:txBody>
       </p:sp>
@@ -6081,7 +6144,7 @@
           <a:noFill/>
         </p:spPr>
         <p:txBody>
-          <a:bodyPr wrap="square" lIns="0" rIns="0" tIns="0" bIns="0" anchor="t">
+          <a:bodyPr wrap="square" lIns="0" tIns="0" rIns="0" bIns="0" anchor="t">
             <a:spAutoFit/>
           </a:bodyPr>
           <a:lstStyle/>
@@ -6120,7 +6183,7 @@
           <a:noFill/>
         </p:spPr>
         <p:txBody>
-          <a:bodyPr wrap="square" lIns="0" rIns="0" tIns="0" bIns="0" anchor="t">
+          <a:bodyPr wrap="square" lIns="0" tIns="0" rIns="0" bIns="0" anchor="t">
             <a:spAutoFit/>
           </a:bodyPr>
           <a:lstStyle/>
@@ -6187,6 +6250,7 @@
           <a:lstStyle/>
           <a:p>
             <a:pPr algn="ctr"/>
+            <a:endParaRPr/>
           </a:p>
         </p:txBody>
       </p:sp>
@@ -6207,7 +6271,7 @@
           <a:noFill/>
         </p:spPr>
         <p:txBody>
-          <a:bodyPr wrap="square" lIns="0" rIns="0" tIns="0" bIns="0" anchor="t">
+          <a:bodyPr wrap="square" lIns="0" tIns="0" rIns="0" bIns="0" anchor="t">
             <a:spAutoFit/>
           </a:bodyPr>
           <a:lstStyle/>
@@ -6246,7 +6310,7 @@
           <a:noFill/>
         </p:spPr>
         <p:txBody>
-          <a:bodyPr wrap="square" lIns="0" rIns="0" tIns="0" bIns="0" anchor="t">
+          <a:bodyPr wrap="square" lIns="0" tIns="0" rIns="0" bIns="0" anchor="t">
             <a:spAutoFit/>
           </a:bodyPr>
           <a:lstStyle/>
@@ -6278,7 +6342,7 @@
 </file>
 
 <file path=ppt/slides/slide4.xml><?xml version="1.0" encoding="utf-8"?>
-<p:sld xmlns:a="http://schemas.openxmlformats.org/drawingml/2006/main" xmlns:p="http://schemas.openxmlformats.org/presentationml/2006/main" xmlns:r="http://schemas.openxmlformats.org/officeDocument/2006/relationships">
+<p:sld xmlns:a="http://schemas.openxmlformats.org/drawingml/2006/main" xmlns:r="http://schemas.openxmlformats.org/officeDocument/2006/relationships" xmlns:p="http://schemas.openxmlformats.org/presentationml/2006/main">
   <p:cSld>
     <p:spTree>
       <p:nvGrpSpPr>
@@ -6286,7 +6350,14 @@
         <p:cNvGrpSpPr/>
         <p:nvPr/>
       </p:nvGrpSpPr>
-      <p:grpSpPr/>
+      <p:grpSpPr>
+        <a:xfrm>
+          <a:off x="0" y="0"/>
+          <a:ext cx="0" cy="0"/>
+          <a:chOff x="0" y="0"/>
+          <a:chExt cx="0" cy="0"/>
+        </a:xfrm>
+      </p:grpSpPr>
       <p:sp>
         <p:nvSpPr>
           <p:cNvPr id="2" name="Rectangle 1"/>
@@ -6328,6 +6399,7 @@
           <a:lstStyle/>
           <a:p>
             <a:pPr algn="ctr"/>
+            <a:endParaRPr/>
           </a:p>
         </p:txBody>
       </p:sp>
@@ -6348,7 +6420,7 @@
           <a:noFill/>
         </p:spPr>
         <p:txBody>
-          <a:bodyPr wrap="square" lIns="0" rIns="0" tIns="0" bIns="0" anchor="t">
+          <a:bodyPr wrap="square" lIns="0" tIns="0" rIns="0" bIns="0" anchor="t">
             <a:spAutoFit/>
           </a:bodyPr>
           <a:lstStyle/>
@@ -6387,7 +6459,7 @@
           <a:noFill/>
         </p:spPr>
         <p:txBody>
-          <a:bodyPr wrap="square" lIns="0" rIns="0" tIns="0" bIns="0" anchor="t">
+          <a:bodyPr wrap="square" lIns="0" tIns="0" rIns="0" bIns="0" anchor="t">
             <a:spAutoFit/>
           </a:bodyPr>
           <a:lstStyle/>
@@ -6452,6 +6524,7 @@
           <a:lstStyle/>
           <a:p>
             <a:pPr algn="ctr"/>
+            <a:endParaRPr/>
           </a:p>
         </p:txBody>
       </p:sp>
@@ -6472,7 +6545,7 @@
           <a:noFill/>
         </p:spPr>
         <p:txBody>
-          <a:bodyPr wrap="square" lIns="0" rIns="0" tIns="0" bIns="0" anchor="t">
+          <a:bodyPr wrap="square" lIns="0" tIns="0" rIns="0" bIns="0" anchor="t">
             <a:spAutoFit/>
           </a:bodyPr>
           <a:lstStyle/>
@@ -6511,7 +6584,7 @@
           <a:noFill/>
         </p:spPr>
         <p:txBody>
-          <a:bodyPr wrap="square" lIns="0" rIns="0" tIns="0" bIns="0" anchor="t">
+          <a:bodyPr wrap="square" lIns="0" tIns="0" rIns="0" bIns="0" anchor="t">
             <a:spAutoFit/>
           </a:bodyPr>
           <a:lstStyle/>
@@ -6576,6 +6649,7 @@
           <a:lstStyle/>
           <a:p>
             <a:pPr algn="ctr"/>
+            <a:endParaRPr/>
           </a:p>
         </p:txBody>
       </p:sp>
@@ -6596,7 +6670,7 @@
           <a:noFill/>
         </p:spPr>
         <p:txBody>
-          <a:bodyPr wrap="square" lIns="0" rIns="0" tIns="0" bIns="0" anchor="t">
+          <a:bodyPr wrap="square" lIns="0" tIns="0" rIns="0" bIns="0" anchor="t">
             <a:spAutoFit/>
           </a:bodyPr>
           <a:lstStyle/>
@@ -6635,7 +6709,7 @@
           <a:noFill/>
         </p:spPr>
         <p:txBody>
-          <a:bodyPr wrap="square" lIns="0" rIns="0" tIns="0" bIns="0" anchor="t">
+          <a:bodyPr wrap="square" lIns="0" tIns="0" rIns="0" bIns="0" anchor="t">
             <a:spAutoFit/>
           </a:bodyPr>
           <a:lstStyle/>
@@ -6700,6 +6774,7 @@
           <a:lstStyle/>
           <a:p>
             <a:pPr algn="ctr"/>
+            <a:endParaRPr/>
           </a:p>
         </p:txBody>
       </p:sp>
@@ -6720,7 +6795,7 @@
           <a:noFill/>
         </p:spPr>
         <p:txBody>
-          <a:bodyPr wrap="square" lIns="0" rIns="0" tIns="0" bIns="0" anchor="t">
+          <a:bodyPr wrap="square" lIns="0" tIns="0" rIns="0" bIns="0" anchor="t">
             <a:spAutoFit/>
           </a:bodyPr>
           <a:lstStyle/>
@@ -6759,7 +6834,7 @@
           <a:noFill/>
         </p:spPr>
         <p:txBody>
-          <a:bodyPr wrap="square" lIns="0" rIns="0" tIns="0" bIns="0" anchor="t">
+          <a:bodyPr wrap="square" lIns="0" tIns="0" rIns="0" bIns="0" anchor="t">
             <a:spAutoFit/>
           </a:bodyPr>
           <a:lstStyle/>
@@ -6826,6 +6901,7 @@
           <a:lstStyle/>
           <a:p>
             <a:pPr algn="ctr"/>
+            <a:endParaRPr/>
           </a:p>
         </p:txBody>
       </p:sp>
@@ -6872,6 +6948,7 @@
           <a:lstStyle/>
           <a:p>
             <a:pPr algn="ctr"/>
+            <a:endParaRPr/>
           </a:p>
         </p:txBody>
       </p:sp>
@@ -6892,7 +6969,7 @@
           <a:noFill/>
         </p:spPr>
         <p:txBody>
-          <a:bodyPr wrap="square" lIns="0" rIns="0" tIns="0" bIns="0" anchor="ctr">
+          <a:bodyPr wrap="square" lIns="0" tIns="0" rIns="0" bIns="0" anchor="ctr">
             <a:spAutoFit/>
           </a:bodyPr>
           <a:lstStyle/>
@@ -6959,6 +7036,7 @@
           <a:lstStyle/>
           <a:p>
             <a:pPr algn="ctr"/>
+            <a:endParaRPr/>
           </a:p>
         </p:txBody>
       </p:sp>
@@ -7005,6 +7083,7 @@
           <a:lstStyle/>
           <a:p>
             <a:pPr algn="ctr"/>
+            <a:endParaRPr/>
           </a:p>
         </p:txBody>
       </p:sp>
@@ -7025,7 +7104,7 @@
           <a:noFill/>
         </p:spPr>
         <p:txBody>
-          <a:bodyPr wrap="square" lIns="0" rIns="0" tIns="0" bIns="0" anchor="t">
+          <a:bodyPr wrap="square" lIns="0" tIns="0" rIns="0" bIns="0" anchor="t">
             <a:spAutoFit/>
           </a:bodyPr>
           <a:lstStyle/>
@@ -7064,7 +7143,7 @@
           <a:noFill/>
         </p:spPr>
         <p:txBody>
-          <a:bodyPr wrap="square" lIns="0" rIns="0" tIns="0" bIns="0" anchor="t">
+          <a:bodyPr wrap="square" lIns="0" tIns="0" rIns="0" bIns="0" anchor="t">
             <a:spAutoFit/>
           </a:bodyPr>
           <a:lstStyle/>
@@ -7131,6 +7210,7 @@
           <a:lstStyle/>
           <a:p>
             <a:pPr algn="ctr"/>
+            <a:endParaRPr/>
           </a:p>
         </p:txBody>
       </p:sp>
@@ -7177,6 +7257,7 @@
           <a:lstStyle/>
           <a:p>
             <a:pPr algn="ctr"/>
+            <a:endParaRPr/>
           </a:p>
         </p:txBody>
       </p:sp>
@@ -7197,7 +7278,7 @@
           <a:noFill/>
         </p:spPr>
         <p:txBody>
-          <a:bodyPr wrap="square" lIns="0" rIns="0" tIns="0" bIns="0" anchor="t">
+          <a:bodyPr wrap="square" lIns="0" tIns="0" rIns="0" bIns="0" anchor="t">
             <a:spAutoFit/>
           </a:bodyPr>
           <a:lstStyle/>
@@ -7236,7 +7317,7 @@
           <a:noFill/>
         </p:spPr>
         <p:txBody>
-          <a:bodyPr wrap="square" lIns="0" rIns="0" tIns="0" bIns="0" anchor="t">
+          <a:bodyPr wrap="square" lIns="0" tIns="0" rIns="0" bIns="0" anchor="t">
             <a:spAutoFit/>
           </a:bodyPr>
           <a:lstStyle/>
@@ -7303,6 +7384,7 @@
           <a:lstStyle/>
           <a:p>
             <a:pPr algn="ctr"/>
+            <a:endParaRPr/>
           </a:p>
         </p:txBody>
       </p:sp>
@@ -7349,6 +7431,7 @@
           <a:lstStyle/>
           <a:p>
             <a:pPr algn="ctr"/>
+            <a:endParaRPr/>
           </a:p>
         </p:txBody>
       </p:sp>
@@ -7369,7 +7452,7 @@
           <a:noFill/>
         </p:spPr>
         <p:txBody>
-          <a:bodyPr wrap="square" lIns="0" rIns="0" tIns="0" bIns="0" anchor="t">
+          <a:bodyPr wrap="square" lIns="0" tIns="0" rIns="0" bIns="0" anchor="t">
             <a:spAutoFit/>
           </a:bodyPr>
           <a:lstStyle/>
@@ -7408,7 +7491,7 @@
           <a:noFill/>
         </p:spPr>
         <p:txBody>
-          <a:bodyPr wrap="square" lIns="0" rIns="0" tIns="0" bIns="0" anchor="t">
+          <a:bodyPr wrap="square" lIns="0" tIns="0" rIns="0" bIns="0" anchor="t">
             <a:spAutoFit/>
           </a:bodyPr>
           <a:lstStyle/>
@@ -7439,7 +7522,7 @@
 </file>
 
 <file path=ppt/slides/slide5.xml><?xml version="1.0" encoding="utf-8"?>
-<p:sld xmlns:a="http://schemas.openxmlformats.org/drawingml/2006/main" xmlns:p="http://schemas.openxmlformats.org/presentationml/2006/main" xmlns:r="http://schemas.openxmlformats.org/officeDocument/2006/relationships">
+<p:sld xmlns:a="http://schemas.openxmlformats.org/drawingml/2006/main" xmlns:r="http://schemas.openxmlformats.org/officeDocument/2006/relationships" xmlns:p="http://schemas.openxmlformats.org/presentationml/2006/main">
   <p:cSld>
     <p:spTree>
       <p:nvGrpSpPr>
@@ -7447,7 +7530,14 @@
         <p:cNvGrpSpPr/>
         <p:nvPr/>
       </p:nvGrpSpPr>
-      <p:grpSpPr/>
+      <p:grpSpPr>
+        <a:xfrm>
+          <a:off x="0" y="0"/>
+          <a:ext cx="0" cy="0"/>
+          <a:chOff x="0" y="0"/>
+          <a:chExt cx="0" cy="0"/>
+        </a:xfrm>
+      </p:grpSpPr>
       <p:sp>
         <p:nvSpPr>
           <p:cNvPr id="2" name="Rectangle 1"/>
@@ -7489,6 +7579,7 @@
           <a:lstStyle/>
           <a:p>
             <a:pPr algn="ctr"/>
+            <a:endParaRPr/>
           </a:p>
         </p:txBody>
       </p:sp>
@@ -7509,7 +7600,7 @@
           <a:noFill/>
         </p:spPr>
         <p:txBody>
-          <a:bodyPr wrap="square" lIns="0" rIns="0" tIns="0" bIns="0" anchor="t">
+          <a:bodyPr wrap="square" lIns="0" tIns="0" rIns="0" bIns="0" anchor="t">
             <a:spAutoFit/>
           </a:bodyPr>
           <a:lstStyle/>
@@ -7548,7 +7639,7 @@
           <a:noFill/>
         </p:spPr>
         <p:txBody>
-          <a:bodyPr wrap="square" lIns="0" rIns="0" tIns="0" bIns="0" anchor="t">
+          <a:bodyPr wrap="square" lIns="0" tIns="0" rIns="0" bIns="0" anchor="t">
             <a:spAutoFit/>
           </a:bodyPr>
           <a:lstStyle/>
@@ -7615,6 +7706,7 @@
           <a:lstStyle/>
           <a:p>
             <a:pPr algn="ctr"/>
+            <a:endParaRPr/>
           </a:p>
         </p:txBody>
       </p:sp>
@@ -7635,7 +7727,7 @@
           <a:noFill/>
         </p:spPr>
         <p:txBody>
-          <a:bodyPr wrap="square" lIns="0" rIns="0" tIns="0" bIns="0" anchor="t">
+          <a:bodyPr wrap="square" lIns="0" tIns="0" rIns="0" bIns="0" anchor="t">
             <a:spAutoFit/>
           </a:bodyPr>
           <a:lstStyle/>
@@ -7674,7 +7766,7 @@
           <a:noFill/>
         </p:spPr>
         <p:txBody>
-          <a:bodyPr wrap="square" lIns="0" rIns="0" tIns="0" bIns="0" anchor="t">
+          <a:bodyPr wrap="square" lIns="0" tIns="0" rIns="0" bIns="0" anchor="t">
             <a:spAutoFit/>
           </a:bodyPr>
           <a:lstStyle/>
@@ -7713,7 +7805,7 @@
           <a:noFill/>
         </p:spPr>
         <p:txBody>
-          <a:bodyPr wrap="square" lIns="0" rIns="0" tIns="0" bIns="0" anchor="t">
+          <a:bodyPr wrap="square" lIns="0" tIns="0" rIns="0" bIns="0" anchor="t">
             <a:spAutoFit/>
           </a:bodyPr>
           <a:lstStyle/>
@@ -7776,6 +7868,7 @@
           <a:lstStyle/>
           <a:p>
             <a:pPr algn="ctr"/>
+            <a:endParaRPr/>
           </a:p>
         </p:txBody>
       </p:sp>
@@ -7824,6 +7917,7 @@
           <a:lstStyle/>
           <a:p>
             <a:pPr algn="ctr"/>
+            <a:endParaRPr/>
           </a:p>
         </p:txBody>
       </p:sp>
@@ -7844,7 +7938,7 @@
           <a:noFill/>
         </p:spPr>
         <p:txBody>
-          <a:bodyPr wrap="square" lIns="0" rIns="0" tIns="0" bIns="0" anchor="t">
+          <a:bodyPr wrap="square" lIns="0" tIns="0" rIns="0" bIns="0" anchor="t">
             <a:spAutoFit/>
           </a:bodyPr>
           <a:lstStyle/>
@@ -7883,7 +7977,7 @@
           <a:noFill/>
         </p:spPr>
         <p:txBody>
-          <a:bodyPr wrap="square" lIns="0" rIns="0" tIns="0" bIns="0" anchor="t">
+          <a:bodyPr wrap="square" lIns="0" tIns="0" rIns="0" bIns="0" anchor="t">
             <a:spAutoFit/>
           </a:bodyPr>
           <a:lstStyle/>
@@ -7922,7 +8016,7 @@
           <a:noFill/>
         </p:spPr>
         <p:txBody>
-          <a:bodyPr wrap="square" lIns="0" rIns="0" tIns="0" bIns="0" anchor="t">
+          <a:bodyPr wrap="square" lIns="0" tIns="0" rIns="0" bIns="0" anchor="t">
             <a:spAutoFit/>
           </a:bodyPr>
           <a:lstStyle/>
@@ -7985,6 +8079,7 @@
           <a:lstStyle/>
           <a:p>
             <a:pPr algn="ctr"/>
+            <a:endParaRPr/>
           </a:p>
         </p:txBody>
       </p:sp>
@@ -8033,6 +8128,7 @@
           <a:lstStyle/>
           <a:p>
             <a:pPr algn="ctr"/>
+            <a:endParaRPr/>
           </a:p>
         </p:txBody>
       </p:sp>
@@ -8053,7 +8149,7 @@
           <a:noFill/>
         </p:spPr>
         <p:txBody>
-          <a:bodyPr wrap="square" lIns="0" rIns="0" tIns="0" bIns="0" anchor="t">
+          <a:bodyPr wrap="square" lIns="0" tIns="0" rIns="0" bIns="0" anchor="t">
             <a:spAutoFit/>
           </a:bodyPr>
           <a:lstStyle/>
@@ -8092,7 +8188,7 @@
           <a:noFill/>
         </p:spPr>
         <p:txBody>
-          <a:bodyPr wrap="square" lIns="0" rIns="0" tIns="0" bIns="0" anchor="t">
+          <a:bodyPr wrap="square" lIns="0" tIns="0" rIns="0" bIns="0" anchor="t">
             <a:spAutoFit/>
           </a:bodyPr>
           <a:lstStyle/>
@@ -8131,7 +8227,7 @@
           <a:noFill/>
         </p:spPr>
         <p:txBody>
-          <a:bodyPr wrap="square" lIns="0" rIns="0" tIns="0" bIns="0" anchor="t">
+          <a:bodyPr wrap="square" lIns="0" tIns="0" rIns="0" bIns="0" anchor="t">
             <a:spAutoFit/>
           </a:bodyPr>
           <a:lstStyle/>
@@ -8194,6 +8290,7 @@
           <a:lstStyle/>
           <a:p>
             <a:pPr algn="ctr"/>
+            <a:endParaRPr/>
           </a:p>
         </p:txBody>
       </p:sp>
@@ -8242,6 +8339,7 @@
           <a:lstStyle/>
           <a:p>
             <a:pPr algn="ctr"/>
+            <a:endParaRPr/>
           </a:p>
         </p:txBody>
       </p:sp>
@@ -8262,7 +8360,7 @@
           <a:noFill/>
         </p:spPr>
         <p:txBody>
-          <a:bodyPr wrap="square" lIns="0" rIns="0" tIns="0" bIns="0" anchor="t">
+          <a:bodyPr wrap="square" lIns="0" tIns="0" rIns="0" bIns="0" anchor="t">
             <a:spAutoFit/>
           </a:bodyPr>
           <a:lstStyle/>
@@ -8301,7 +8399,7 @@
           <a:noFill/>
         </p:spPr>
         <p:txBody>
-          <a:bodyPr wrap="square" lIns="0" rIns="0" tIns="0" bIns="0" anchor="t">
+          <a:bodyPr wrap="square" lIns="0" tIns="0" rIns="0" bIns="0" anchor="t">
             <a:spAutoFit/>
           </a:bodyPr>
           <a:lstStyle/>
@@ -8340,7 +8438,7 @@
           <a:noFill/>
         </p:spPr>
         <p:txBody>
-          <a:bodyPr wrap="square" lIns="0" rIns="0" tIns="0" bIns="0" anchor="t">
+          <a:bodyPr wrap="square" lIns="0" tIns="0" rIns="0" bIns="0" anchor="t">
             <a:spAutoFit/>
           </a:bodyPr>
           <a:lstStyle/>
@@ -8370,7 +8468,7 @@
         </p:nvSpPr>
         <p:spPr>
           <a:xfrm>
-            <a:off x="777240" y="6355080"/>
+            <a:off x="777240" y="6195060"/>
             <a:ext cx="10607040" cy="320040"/>
           </a:xfrm>
           <a:prstGeom prst="rect">
@@ -8379,7 +8477,7 @@
           <a:noFill/>
         </p:spPr>
         <p:txBody>
-          <a:bodyPr wrap="square" lIns="0" rIns="0" tIns="0" bIns="0" anchor="t">
+          <a:bodyPr wrap="square" lIns="0" tIns="0" rIns="0" bIns="0" anchor="t">
             <a:spAutoFit/>
           </a:bodyPr>
           <a:lstStyle/>
@@ -8410,7 +8508,7 @@
 </file>
 
 <file path=ppt/slides/slide6.xml><?xml version="1.0" encoding="utf-8"?>
-<p:sld xmlns:a="http://schemas.openxmlformats.org/drawingml/2006/main" xmlns:p="http://schemas.openxmlformats.org/presentationml/2006/main" xmlns:r="http://schemas.openxmlformats.org/officeDocument/2006/relationships">
+<p:sld xmlns:a="http://schemas.openxmlformats.org/drawingml/2006/main" xmlns:r="http://schemas.openxmlformats.org/officeDocument/2006/relationships" xmlns:p="http://schemas.openxmlformats.org/presentationml/2006/main">
   <p:cSld>
     <p:spTree>
       <p:nvGrpSpPr>
@@ -8418,7 +8516,14 @@
         <p:cNvGrpSpPr/>
         <p:nvPr/>
       </p:nvGrpSpPr>
-      <p:grpSpPr/>
+      <p:grpSpPr>
+        <a:xfrm>
+          <a:off x="0" y="0"/>
+          <a:ext cx="0" cy="0"/>
+          <a:chOff x="0" y="0"/>
+          <a:chExt cx="0" cy="0"/>
+        </a:xfrm>
+      </p:grpSpPr>
       <p:sp>
         <p:nvSpPr>
           <p:cNvPr id="2" name="Rectangle 1"/>
@@ -8460,6 +8565,7 @@
           <a:lstStyle/>
           <a:p>
             <a:pPr algn="ctr"/>
+            <a:endParaRPr/>
           </a:p>
         </p:txBody>
       </p:sp>
@@ -8480,7 +8586,7 @@
           <a:noFill/>
         </p:spPr>
         <p:txBody>
-          <a:bodyPr wrap="square" lIns="0" rIns="0" tIns="0" bIns="0" anchor="t">
+          <a:bodyPr wrap="square" lIns="0" tIns="0" rIns="0" bIns="0" anchor="t">
             <a:spAutoFit/>
           </a:bodyPr>
           <a:lstStyle/>
@@ -8519,7 +8625,7 @@
           <a:noFill/>
         </p:spPr>
         <p:txBody>
-          <a:bodyPr wrap="square" lIns="0" rIns="0" tIns="0" bIns="0" anchor="t">
+          <a:bodyPr wrap="square" lIns="0" tIns="0" rIns="0" bIns="0" anchor="t">
             <a:spAutoFit/>
           </a:bodyPr>
           <a:lstStyle/>
@@ -8558,7 +8664,7 @@
           <a:noFill/>
         </p:spPr>
         <p:txBody>
-          <a:bodyPr wrap="square" lIns="0" rIns="0" tIns="0" bIns="0" anchor="t">
+          <a:bodyPr wrap="square" lIns="0" tIns="0" rIns="0" bIns="0" anchor="t">
             <a:spAutoFit/>
           </a:bodyPr>
           <a:lstStyle/>
@@ -8597,7 +8703,7 @@
           <a:noFill/>
         </p:spPr>
         <p:txBody>
-          <a:bodyPr wrap="square" lIns="0" rIns="0" tIns="0" bIns="0" anchor="t">
+          <a:bodyPr wrap="square" lIns="0" tIns="0" rIns="0" bIns="0" anchor="t">
             <a:spAutoFit/>
           </a:bodyPr>
           <a:lstStyle/>
@@ -8636,7 +8742,7 @@
           <a:noFill/>
         </p:spPr>
         <p:txBody>
-          <a:bodyPr wrap="square" lIns="0" rIns="0" tIns="0" bIns="0" anchor="t">
+          <a:bodyPr wrap="square" lIns="0" tIns="0" rIns="0" bIns="0" anchor="t">
             <a:spAutoFit/>
           </a:bodyPr>
           <a:lstStyle/>
@@ -8675,7 +8781,7 @@
           <a:noFill/>
         </p:spPr>
         <p:txBody>
-          <a:bodyPr wrap="square" lIns="0" rIns="0" tIns="0" bIns="0" anchor="t">
+          <a:bodyPr wrap="square" lIns="0" tIns="0" rIns="0" bIns="0" anchor="t">
             <a:spAutoFit/>
           </a:bodyPr>
           <a:lstStyle/>
@@ -8714,7 +8820,7 @@
           <a:noFill/>
         </p:spPr>
         <p:txBody>
-          <a:bodyPr wrap="square" lIns="0" rIns="0" tIns="0" bIns="0" anchor="t">
+          <a:bodyPr wrap="square" lIns="0" tIns="0" rIns="0" bIns="0" anchor="t">
             <a:spAutoFit/>
           </a:bodyPr>
           <a:lstStyle/>
@@ -8753,7 +8859,7 @@
           <a:noFill/>
         </p:spPr>
         <p:txBody>
-          <a:bodyPr wrap="square" lIns="0" rIns="0" tIns="0" bIns="0" anchor="t">
+          <a:bodyPr wrap="square" lIns="0" tIns="0" rIns="0" bIns="0" anchor="t">
             <a:spAutoFit/>
           </a:bodyPr>
           <a:lstStyle/>
@@ -8792,7 +8898,7 @@
           <a:noFill/>
         </p:spPr>
         <p:txBody>
-          <a:bodyPr wrap="square" lIns="0" rIns="0" tIns="0" bIns="0" anchor="t">
+          <a:bodyPr wrap="square" lIns="0" tIns="0" rIns="0" bIns="0" anchor="t">
             <a:spAutoFit/>
           </a:bodyPr>
           <a:lstStyle/>
@@ -8831,7 +8937,7 @@
           <a:noFill/>
         </p:spPr>
         <p:txBody>
-          <a:bodyPr wrap="square" lIns="0" rIns="0" tIns="0" bIns="0" anchor="t">
+          <a:bodyPr wrap="square" lIns="0" tIns="0" rIns="0" bIns="0" anchor="t">
             <a:spAutoFit/>
           </a:bodyPr>
           <a:lstStyle/>
@@ -8870,7 +8976,7 @@
           <a:noFill/>
         </p:spPr>
         <p:txBody>
-          <a:bodyPr wrap="square" lIns="0" rIns="0" tIns="0" bIns="0" anchor="t">
+          <a:bodyPr wrap="square" lIns="0" tIns="0" rIns="0" bIns="0" anchor="t">
             <a:spAutoFit/>
           </a:bodyPr>
           <a:lstStyle/>
@@ -8909,7 +9015,7 @@
           <a:noFill/>
         </p:spPr>
         <p:txBody>
-          <a:bodyPr wrap="square" lIns="0" rIns="0" tIns="0" bIns="0" anchor="t">
+          <a:bodyPr wrap="square" lIns="0" tIns="0" rIns="0" bIns="0" anchor="t">
             <a:spAutoFit/>
           </a:bodyPr>
           <a:lstStyle/>
@@ -8948,7 +9054,7 @@
           <a:noFill/>
         </p:spPr>
         <p:txBody>
-          <a:bodyPr wrap="square" lIns="0" rIns="0" tIns="0" bIns="0" anchor="t">
+          <a:bodyPr wrap="square" lIns="0" tIns="0" rIns="0" bIns="0" anchor="t">
             <a:spAutoFit/>
           </a:bodyPr>
           <a:lstStyle/>
@@ -8987,7 +9093,7 @@
           <a:noFill/>
         </p:spPr>
         <p:txBody>
-          <a:bodyPr wrap="square" lIns="0" rIns="0" tIns="0" bIns="0" anchor="t">
+          <a:bodyPr wrap="square" lIns="0" tIns="0" rIns="0" bIns="0" anchor="t">
             <a:spAutoFit/>
           </a:bodyPr>
           <a:lstStyle/>
@@ -9052,6 +9158,7 @@
           <a:lstStyle/>
           <a:p>
             <a:pPr algn="ctr"/>
+            <a:endParaRPr/>
           </a:p>
         </p:txBody>
       </p:sp>
@@ -9072,7 +9179,7 @@
           <a:noFill/>
         </p:spPr>
         <p:txBody>
-          <a:bodyPr wrap="square" lIns="0" rIns="0" tIns="0" bIns="0" anchor="ctr">
+          <a:bodyPr wrap="square" lIns="0" tIns="0" rIns="0" bIns="0" anchor="ctr">
             <a:spAutoFit/>
           </a:bodyPr>
           <a:lstStyle/>
@@ -9103,7 +9210,7 @@
 </file>
 
 <file path=ppt/slides/slide7.xml><?xml version="1.0" encoding="utf-8"?>
-<p:sld xmlns:a="http://schemas.openxmlformats.org/drawingml/2006/main" xmlns:p="http://schemas.openxmlformats.org/presentationml/2006/main" xmlns:r="http://schemas.openxmlformats.org/officeDocument/2006/relationships">
+<p:sld xmlns:a="http://schemas.openxmlformats.org/drawingml/2006/main" xmlns:r="http://schemas.openxmlformats.org/officeDocument/2006/relationships" xmlns:p="http://schemas.openxmlformats.org/presentationml/2006/main">
   <p:cSld>
     <p:spTree>
       <p:nvGrpSpPr>
@@ -9111,7 +9218,14 @@
         <p:cNvGrpSpPr/>
         <p:nvPr/>
       </p:nvGrpSpPr>
-      <p:grpSpPr/>
+      <p:grpSpPr>
+        <a:xfrm>
+          <a:off x="0" y="0"/>
+          <a:ext cx="0" cy="0"/>
+          <a:chOff x="0" y="0"/>
+          <a:chExt cx="0" cy="0"/>
+        </a:xfrm>
+      </p:grpSpPr>
       <p:sp>
         <p:nvSpPr>
           <p:cNvPr id="2" name="Rectangle 1"/>
@@ -9153,6 +9267,7 @@
           <a:lstStyle/>
           <a:p>
             <a:pPr algn="ctr"/>
+            <a:endParaRPr/>
           </a:p>
         </p:txBody>
       </p:sp>
@@ -9173,7 +9288,7 @@
           <a:noFill/>
         </p:spPr>
         <p:txBody>
-          <a:bodyPr wrap="square" lIns="0" rIns="0" tIns="0" bIns="0" anchor="t">
+          <a:bodyPr wrap="square" lIns="0" tIns="0" rIns="0" bIns="0" anchor="t">
             <a:spAutoFit/>
           </a:bodyPr>
           <a:lstStyle/>
@@ -9212,7 +9327,7 @@
           <a:noFill/>
         </p:spPr>
         <p:txBody>
-          <a:bodyPr wrap="square" lIns="0" rIns="0" tIns="0" bIns="0" anchor="t">
+          <a:bodyPr wrap="square" lIns="0" tIns="0" rIns="0" bIns="0" anchor="t">
             <a:spAutoFit/>
           </a:bodyPr>
           <a:lstStyle/>
@@ -9279,6 +9394,7 @@
           <a:lstStyle/>
           <a:p>
             <a:pPr algn="ctr"/>
+            <a:endParaRPr/>
           </a:p>
         </p:txBody>
       </p:sp>
@@ -9299,7 +9415,7 @@
           <a:noFill/>
         </p:spPr>
         <p:txBody>
-          <a:bodyPr wrap="square" lIns="0" rIns="0" tIns="0" bIns="0" anchor="ctr">
+          <a:bodyPr wrap="square" lIns="0" tIns="0" rIns="0" bIns="0" anchor="ctr">
             <a:spAutoFit/>
           </a:bodyPr>
           <a:lstStyle/>
@@ -9338,7 +9454,7 @@
           <a:noFill/>
         </p:spPr>
         <p:txBody>
-          <a:bodyPr wrap="square" lIns="0" rIns="0" tIns="0" bIns="0" anchor="t">
+          <a:bodyPr wrap="square" lIns="0" tIns="0" rIns="0" bIns="0" anchor="t">
             <a:spAutoFit/>
           </a:bodyPr>
           <a:lstStyle/>
@@ -9377,7 +9493,7 @@
           <a:noFill/>
         </p:spPr>
         <p:txBody>
-          <a:bodyPr wrap="square" lIns="0" rIns="0" tIns="0" bIns="0" anchor="t">
+          <a:bodyPr wrap="square" lIns="0" tIns="0" rIns="0" bIns="0" anchor="t">
             <a:spAutoFit/>
           </a:bodyPr>
           <a:lstStyle/>
@@ -9444,6 +9560,7 @@
           <a:lstStyle/>
           <a:p>
             <a:pPr algn="ctr"/>
+            <a:endParaRPr/>
           </a:p>
         </p:txBody>
       </p:sp>
@@ -9464,7 +9581,7 @@
           <a:noFill/>
         </p:spPr>
         <p:txBody>
-          <a:bodyPr wrap="square" lIns="0" rIns="0" tIns="0" bIns="0" anchor="ctr">
+          <a:bodyPr wrap="square" lIns="0" tIns="0" rIns="0" bIns="0" anchor="ctr">
             <a:spAutoFit/>
           </a:bodyPr>
           <a:lstStyle/>
@@ -9503,7 +9620,7 @@
           <a:noFill/>
         </p:spPr>
         <p:txBody>
-          <a:bodyPr wrap="square" lIns="0" rIns="0" tIns="0" bIns="0" anchor="t">
+          <a:bodyPr wrap="square" lIns="0" tIns="0" rIns="0" bIns="0" anchor="t">
             <a:spAutoFit/>
           </a:bodyPr>
           <a:lstStyle/>
@@ -9542,7 +9659,7 @@
           <a:noFill/>
         </p:spPr>
         <p:txBody>
-          <a:bodyPr wrap="square" lIns="0" rIns="0" tIns="0" bIns="0" anchor="t">
+          <a:bodyPr wrap="square" lIns="0" tIns="0" rIns="0" bIns="0" anchor="t">
             <a:spAutoFit/>
           </a:bodyPr>
           <a:lstStyle/>
@@ -9609,6 +9726,7 @@
           <a:lstStyle/>
           <a:p>
             <a:pPr algn="ctr"/>
+            <a:endParaRPr/>
           </a:p>
         </p:txBody>
       </p:sp>
@@ -9629,7 +9747,7 @@
           <a:noFill/>
         </p:spPr>
         <p:txBody>
-          <a:bodyPr wrap="square" lIns="0" rIns="0" tIns="0" bIns="0" anchor="ctr">
+          <a:bodyPr wrap="square" lIns="0" tIns="0" rIns="0" bIns="0" anchor="ctr">
             <a:spAutoFit/>
           </a:bodyPr>
           <a:lstStyle/>
@@ -9668,7 +9786,7 @@
           <a:noFill/>
         </p:spPr>
         <p:txBody>
-          <a:bodyPr wrap="square" lIns="0" rIns="0" tIns="0" bIns="0" anchor="t">
+          <a:bodyPr wrap="square" lIns="0" tIns="0" rIns="0" bIns="0" anchor="t">
             <a:spAutoFit/>
           </a:bodyPr>
           <a:lstStyle/>
@@ -9707,7 +9825,7 @@
           <a:noFill/>
         </p:spPr>
         <p:txBody>
-          <a:bodyPr wrap="square" lIns="0" rIns="0" tIns="0" bIns="0" anchor="t">
+          <a:bodyPr wrap="square" lIns="0" tIns="0" rIns="0" bIns="0" anchor="t">
             <a:spAutoFit/>
           </a:bodyPr>
           <a:lstStyle/>
@@ -9774,6 +9892,7 @@
           <a:lstStyle/>
           <a:p>
             <a:pPr algn="ctr"/>
+            <a:endParaRPr/>
           </a:p>
         </p:txBody>
       </p:sp>
@@ -9794,7 +9913,7 @@
           <a:noFill/>
         </p:spPr>
         <p:txBody>
-          <a:bodyPr wrap="square" lIns="0" rIns="0" tIns="0" bIns="0" anchor="ctr">
+          <a:bodyPr wrap="square" lIns="0" tIns="0" rIns="0" bIns="0" anchor="ctr">
             <a:spAutoFit/>
           </a:bodyPr>
           <a:lstStyle/>
@@ -9833,7 +9952,7 @@
           <a:noFill/>
         </p:spPr>
         <p:txBody>
-          <a:bodyPr wrap="square" lIns="0" rIns="0" tIns="0" bIns="0" anchor="t">
+          <a:bodyPr wrap="square" lIns="0" tIns="0" rIns="0" bIns="0" anchor="t">
             <a:spAutoFit/>
           </a:bodyPr>
           <a:lstStyle/>
@@ -9872,7 +9991,7 @@
           <a:noFill/>
         </p:spPr>
         <p:txBody>
-          <a:bodyPr wrap="square" lIns="0" rIns="0" tIns="0" bIns="0" anchor="t">
+          <a:bodyPr wrap="square" lIns="0" tIns="0" rIns="0" bIns="0" anchor="t">
             <a:spAutoFit/>
           </a:bodyPr>
           <a:lstStyle/>
@@ -9903,7 +10022,7 @@
 </file>
 
 <file path=ppt/slides/slide8.xml><?xml version="1.0" encoding="utf-8"?>
-<p:sld xmlns:a="http://schemas.openxmlformats.org/drawingml/2006/main" xmlns:p="http://schemas.openxmlformats.org/presentationml/2006/main" xmlns:r="http://schemas.openxmlformats.org/officeDocument/2006/relationships">
+<p:sld xmlns:a="http://schemas.openxmlformats.org/drawingml/2006/main" xmlns:r="http://schemas.openxmlformats.org/officeDocument/2006/relationships" xmlns:p="http://schemas.openxmlformats.org/presentationml/2006/main">
   <p:cSld>
     <p:spTree>
       <p:nvGrpSpPr>
@@ -9911,7 +10030,14 @@
         <p:cNvGrpSpPr/>
         <p:nvPr/>
       </p:nvGrpSpPr>
-      <p:grpSpPr/>
+      <p:grpSpPr>
+        <a:xfrm>
+          <a:off x="0" y="0"/>
+          <a:ext cx="0" cy="0"/>
+          <a:chOff x="0" y="0"/>
+          <a:chExt cx="0" cy="0"/>
+        </a:xfrm>
+      </p:grpSpPr>
       <p:sp>
         <p:nvSpPr>
           <p:cNvPr id="2" name="Rectangle 1"/>
@@ -9953,6 +10079,7 @@
           <a:lstStyle/>
           <a:p>
             <a:pPr algn="ctr"/>
+            <a:endParaRPr/>
           </a:p>
         </p:txBody>
       </p:sp>
@@ -9973,7 +10100,7 @@
           <a:noFill/>
         </p:spPr>
         <p:txBody>
-          <a:bodyPr wrap="square" lIns="0" rIns="0" tIns="0" bIns="0" anchor="t">
+          <a:bodyPr wrap="square" lIns="0" tIns="0" rIns="0" bIns="0" anchor="t">
             <a:spAutoFit/>
           </a:bodyPr>
           <a:lstStyle/>
@@ -10012,7 +10139,7 @@
           <a:noFill/>
         </p:spPr>
         <p:txBody>
-          <a:bodyPr wrap="square" lIns="0" rIns="0" tIns="0" bIns="0" anchor="t">
+          <a:bodyPr wrap="square" lIns="0" tIns="0" rIns="0" bIns="0" anchor="t">
             <a:spAutoFit/>
           </a:bodyPr>
           <a:lstStyle/>
@@ -10079,6 +10206,7 @@
           <a:lstStyle/>
           <a:p>
             <a:pPr algn="ctr"/>
+            <a:endParaRPr/>
           </a:p>
         </p:txBody>
       </p:sp>
@@ -10099,7 +10227,7 @@
           <a:noFill/>
         </p:spPr>
         <p:txBody>
-          <a:bodyPr wrap="square" lIns="0" rIns="0" tIns="0" bIns="0" anchor="ctr">
+          <a:bodyPr wrap="square" lIns="0" tIns="0" rIns="0" bIns="0" anchor="ctr">
             <a:spAutoFit/>
           </a:bodyPr>
           <a:lstStyle/>
@@ -10138,7 +10266,7 @@
           <a:noFill/>
         </p:spPr>
         <p:txBody>
-          <a:bodyPr wrap="square" lIns="0" rIns="0" tIns="0" bIns="0" anchor="t">
+          <a:bodyPr wrap="square" lIns="0" tIns="0" rIns="0" bIns="0" anchor="t">
             <a:spAutoFit/>
           </a:bodyPr>
           <a:lstStyle/>
@@ -10177,7 +10305,7 @@
           <a:noFill/>
         </p:spPr>
         <p:txBody>
-          <a:bodyPr wrap="square" lIns="0" rIns="0" tIns="0" bIns="0" anchor="t">
+          <a:bodyPr wrap="square" lIns="0" tIns="0" rIns="0" bIns="0" anchor="t">
             <a:spAutoFit/>
           </a:bodyPr>
           <a:lstStyle/>
@@ -10244,6 +10372,7 @@
           <a:lstStyle/>
           <a:p>
             <a:pPr algn="ctr"/>
+            <a:endParaRPr/>
           </a:p>
         </p:txBody>
       </p:sp>
@@ -10264,7 +10393,7 @@
           <a:noFill/>
         </p:spPr>
         <p:txBody>
-          <a:bodyPr wrap="square" lIns="0" rIns="0" tIns="0" bIns="0" anchor="ctr">
+          <a:bodyPr wrap="square" lIns="0" tIns="0" rIns="0" bIns="0" anchor="ctr">
             <a:spAutoFit/>
           </a:bodyPr>
           <a:lstStyle/>
@@ -10303,7 +10432,7 @@
           <a:noFill/>
         </p:spPr>
         <p:txBody>
-          <a:bodyPr wrap="square" lIns="0" rIns="0" tIns="0" bIns="0" anchor="t">
+          <a:bodyPr wrap="square" lIns="0" tIns="0" rIns="0" bIns="0" anchor="t">
             <a:spAutoFit/>
           </a:bodyPr>
           <a:lstStyle/>
@@ -10342,7 +10471,7 @@
           <a:noFill/>
         </p:spPr>
         <p:txBody>
-          <a:bodyPr wrap="square" lIns="0" rIns="0" tIns="0" bIns="0" anchor="t">
+          <a:bodyPr wrap="square" lIns="0" tIns="0" rIns="0" bIns="0" anchor="t">
             <a:spAutoFit/>
           </a:bodyPr>
           <a:lstStyle/>
@@ -10409,6 +10538,7 @@
           <a:lstStyle/>
           <a:p>
             <a:pPr algn="ctr"/>
+            <a:endParaRPr/>
           </a:p>
         </p:txBody>
       </p:sp>
@@ -10429,7 +10559,7 @@
           <a:noFill/>
         </p:spPr>
         <p:txBody>
-          <a:bodyPr wrap="square" lIns="0" rIns="0" tIns="0" bIns="0" anchor="ctr">
+          <a:bodyPr wrap="square" lIns="0" tIns="0" rIns="0" bIns="0" anchor="ctr">
             <a:spAutoFit/>
           </a:bodyPr>
           <a:lstStyle/>
@@ -10468,7 +10598,7 @@
           <a:noFill/>
         </p:spPr>
         <p:txBody>
-          <a:bodyPr wrap="square" lIns="0" rIns="0" tIns="0" bIns="0" anchor="t">
+          <a:bodyPr wrap="square" lIns="0" tIns="0" rIns="0" bIns="0" anchor="t">
             <a:spAutoFit/>
           </a:bodyPr>
           <a:lstStyle/>
@@ -10507,7 +10637,7 @@
           <a:noFill/>
         </p:spPr>
         <p:txBody>
-          <a:bodyPr wrap="square" lIns="0" rIns="0" tIns="0" bIns="0" anchor="t">
+          <a:bodyPr wrap="square" lIns="0" tIns="0" rIns="0" bIns="0" anchor="t">
             <a:spAutoFit/>
           </a:bodyPr>
           <a:lstStyle/>
@@ -10574,6 +10704,7 @@
           <a:lstStyle/>
           <a:p>
             <a:pPr algn="ctr"/>
+            <a:endParaRPr/>
           </a:p>
         </p:txBody>
       </p:sp>
@@ -10594,7 +10725,7 @@
           <a:noFill/>
         </p:spPr>
         <p:txBody>
-          <a:bodyPr wrap="square" lIns="0" rIns="0" tIns="0" bIns="0" anchor="ctr">
+          <a:bodyPr wrap="square" lIns="0" tIns="0" rIns="0" bIns="0" anchor="ctr">
             <a:spAutoFit/>
           </a:bodyPr>
           <a:lstStyle/>
@@ -10633,7 +10764,7 @@
           <a:noFill/>
         </p:spPr>
         <p:txBody>
-          <a:bodyPr wrap="square" lIns="0" rIns="0" tIns="0" bIns="0" anchor="t">
+          <a:bodyPr wrap="square" lIns="0" tIns="0" rIns="0" bIns="0" anchor="t">
             <a:spAutoFit/>
           </a:bodyPr>
           <a:lstStyle/>
@@ -10672,7 +10803,7 @@
           <a:noFill/>
         </p:spPr>
         <p:txBody>
-          <a:bodyPr wrap="square" lIns="0" rIns="0" tIns="0" bIns="0" anchor="t">
+          <a:bodyPr wrap="square" lIns="0" tIns="0" rIns="0" bIns="0" anchor="t">
             <a:spAutoFit/>
           </a:bodyPr>
           <a:lstStyle/>
@@ -10703,7 +10834,7 @@
 </file>
 
 <file path=ppt/slides/slide9.xml><?xml version="1.0" encoding="utf-8"?>
-<p:sld xmlns:a="http://schemas.openxmlformats.org/drawingml/2006/main" xmlns:p="http://schemas.openxmlformats.org/presentationml/2006/main" xmlns:r="http://schemas.openxmlformats.org/officeDocument/2006/relationships">
+<p:sld xmlns:a="http://schemas.openxmlformats.org/drawingml/2006/main" xmlns:r="http://schemas.openxmlformats.org/officeDocument/2006/relationships" xmlns:p="http://schemas.openxmlformats.org/presentationml/2006/main">
   <p:cSld>
     <p:spTree>
       <p:nvGrpSpPr>
@@ -10711,7 +10842,14 @@
         <p:cNvGrpSpPr/>
         <p:nvPr/>
       </p:nvGrpSpPr>
-      <p:grpSpPr/>
+      <p:grpSpPr>
+        <a:xfrm>
+          <a:off x="0" y="0"/>
+          <a:ext cx="0" cy="0"/>
+          <a:chOff x="0" y="0"/>
+          <a:chExt cx="0" cy="0"/>
+        </a:xfrm>
+      </p:grpSpPr>
       <p:sp>
         <p:nvSpPr>
           <p:cNvPr id="2" name="Rectangle 1"/>
@@ -10753,6 +10891,7 @@
           <a:lstStyle/>
           <a:p>
             <a:pPr algn="ctr"/>
+            <a:endParaRPr/>
           </a:p>
         </p:txBody>
       </p:sp>
@@ -10773,7 +10912,7 @@
           <a:noFill/>
         </p:spPr>
         <p:txBody>
-          <a:bodyPr wrap="square" lIns="0" rIns="0" tIns="0" bIns="0" anchor="t">
+          <a:bodyPr wrap="square" lIns="0" tIns="0" rIns="0" bIns="0" anchor="t">
             <a:spAutoFit/>
           </a:bodyPr>
           <a:lstStyle/>
@@ -10812,7 +10951,7 @@
           <a:noFill/>
         </p:spPr>
         <p:txBody>
-          <a:bodyPr wrap="square" lIns="0" rIns="0" tIns="0" bIns="0" anchor="t">
+          <a:bodyPr wrap="square" lIns="0" tIns="0" rIns="0" bIns="0" anchor="t">
             <a:spAutoFit/>
           </a:bodyPr>
           <a:lstStyle/>
@@ -10879,6 +11018,7 @@
           <a:lstStyle/>
           <a:p>
             <a:pPr algn="ctr"/>
+            <a:endParaRPr/>
           </a:p>
         </p:txBody>
       </p:sp>
@@ -10899,7 +11039,7 @@
           <a:noFill/>
         </p:spPr>
         <p:txBody>
-          <a:bodyPr wrap="square" lIns="0" rIns="0" tIns="0" bIns="0" anchor="ctr">
+          <a:bodyPr wrap="square" lIns="0" tIns="0" rIns="0" bIns="0" anchor="ctr">
             <a:spAutoFit/>
           </a:bodyPr>
           <a:lstStyle/>
@@ -10909,15 +11049,7 @@
                 <a:spcPct val="115000"/>
               </a:lnSpc>
             </a:pPr>
-            <a:r>
-              <a:rPr sz="1150" b="1">
-                <a:solidFill>
-                  <a:srgbClr val="26221E"/>
-                </a:solidFill>
-                <a:latin typeface="Segoe UI Semibold"/>
-              </a:rPr>
-              <a:t/>
-            </a:r>
+            <a:endParaRPr/>
           </a:p>
         </p:txBody>
       </p:sp>
@@ -10966,6 +11098,7 @@
           <a:lstStyle/>
           <a:p>
             <a:pPr algn="ctr"/>
+            <a:endParaRPr/>
           </a:p>
         </p:txBody>
       </p:sp>
@@ -10986,7 +11119,7 @@
           <a:noFill/>
         </p:spPr>
         <p:txBody>
-          <a:bodyPr wrap="square" lIns="0" rIns="0" tIns="0" bIns="0" anchor="ctr">
+          <a:bodyPr wrap="square" lIns="0" tIns="0" rIns="0" bIns="0" anchor="ctr">
             <a:spAutoFit/>
           </a:bodyPr>
           <a:lstStyle/>
@@ -11054,6 +11187,7 @@
           <a:lstStyle/>
           <a:p>
             <a:pPr algn="ctr"/>
+            <a:endParaRPr/>
           </a:p>
         </p:txBody>
       </p:sp>
@@ -11074,7 +11208,7 @@
           <a:noFill/>
         </p:spPr>
         <p:txBody>
-          <a:bodyPr wrap="square" lIns="0" rIns="0" tIns="0" bIns="0" anchor="ctr">
+          <a:bodyPr wrap="square" lIns="0" tIns="0" rIns="0" bIns="0" anchor="ctr">
             <a:spAutoFit/>
           </a:bodyPr>
           <a:lstStyle/>
@@ -11142,6 +11276,7 @@
           <a:lstStyle/>
           <a:p>
             <a:pPr algn="ctr"/>
+            <a:endParaRPr/>
           </a:p>
         </p:txBody>
       </p:sp>
@@ -11162,7 +11297,7 @@
           <a:noFill/>
         </p:spPr>
         <p:txBody>
-          <a:bodyPr wrap="square" lIns="0" rIns="0" tIns="0" bIns="0" anchor="ctr">
+          <a:bodyPr wrap="square" lIns="0" tIns="0" rIns="0" bIns="0" anchor="ctr">
             <a:spAutoFit/>
           </a:bodyPr>
           <a:lstStyle/>
@@ -11230,6 +11365,7 @@
           <a:lstStyle/>
           <a:p>
             <a:pPr algn="ctr"/>
+            <a:endParaRPr/>
           </a:p>
         </p:txBody>
       </p:sp>
@@ -11250,7 +11386,7 @@
           <a:noFill/>
         </p:spPr>
         <p:txBody>
-          <a:bodyPr wrap="square" lIns="0" rIns="0" tIns="0" bIns="0" anchor="ctr">
+          <a:bodyPr wrap="square" lIns="0" tIns="0" rIns="0" bIns="0" anchor="ctr">
             <a:spAutoFit/>
           </a:bodyPr>
           <a:lstStyle/>
@@ -11317,6 +11453,7 @@
           <a:lstStyle/>
           <a:p>
             <a:pPr algn="ctr"/>
+            <a:endParaRPr/>
           </a:p>
         </p:txBody>
       </p:sp>
@@ -11337,7 +11474,7 @@
           <a:noFill/>
         </p:spPr>
         <p:txBody>
-          <a:bodyPr wrap="square" lIns="0" rIns="0" tIns="0" bIns="0" anchor="ctr">
+          <a:bodyPr wrap="square" lIns="0" tIns="0" rIns="0" bIns="0" anchor="ctr">
             <a:spAutoFit/>
           </a:bodyPr>
           <a:lstStyle/>
@@ -11404,6 +11541,7 @@
           <a:lstStyle/>
           <a:p>
             <a:pPr algn="ctr"/>
+            <a:endParaRPr/>
           </a:p>
         </p:txBody>
       </p:sp>
@@ -11424,7 +11562,7 @@
           <a:noFill/>
         </p:spPr>
         <p:txBody>
-          <a:bodyPr wrap="square" lIns="0" rIns="0" tIns="0" bIns="0" anchor="ctr">
+          <a:bodyPr wrap="square" lIns="0" tIns="0" rIns="0" bIns="0" anchor="ctr">
             <a:spAutoFit/>
           </a:bodyPr>
           <a:lstStyle/>
@@ -11491,6 +11629,7 @@
           <a:lstStyle/>
           <a:p>
             <a:pPr algn="ctr"/>
+            <a:endParaRPr/>
           </a:p>
         </p:txBody>
       </p:sp>
@@ -11511,7 +11650,7 @@
           <a:noFill/>
         </p:spPr>
         <p:txBody>
-          <a:bodyPr wrap="square" lIns="0" rIns="0" tIns="0" bIns="0" anchor="ctr">
+          <a:bodyPr wrap="square" lIns="0" tIns="0" rIns="0" bIns="0" anchor="ctr">
             <a:spAutoFit/>
           </a:bodyPr>
           <a:lstStyle/>
@@ -11578,6 +11717,7 @@
           <a:lstStyle/>
           <a:p>
             <a:pPr algn="ctr"/>
+            <a:endParaRPr/>
           </a:p>
         </p:txBody>
       </p:sp>
@@ -11598,7 +11738,7 @@
           <a:noFill/>
         </p:spPr>
         <p:txBody>
-          <a:bodyPr wrap="square" lIns="0" rIns="0" tIns="0" bIns="0" anchor="ctr">
+          <a:bodyPr wrap="square" lIns="0" tIns="0" rIns="0" bIns="0" anchor="ctr">
             <a:spAutoFit/>
           </a:bodyPr>
           <a:lstStyle/>
@@ -11665,6 +11805,7 @@
           <a:lstStyle/>
           <a:p>
             <a:pPr algn="ctr"/>
+            <a:endParaRPr/>
           </a:p>
         </p:txBody>
       </p:sp>
@@ -11685,7 +11826,7 @@
           <a:noFill/>
         </p:spPr>
         <p:txBody>
-          <a:bodyPr wrap="square" lIns="0" rIns="0" tIns="0" bIns="0" anchor="ctr">
+          <a:bodyPr wrap="square" lIns="0" tIns="0" rIns="0" bIns="0" anchor="ctr">
             <a:spAutoFit/>
           </a:bodyPr>
           <a:lstStyle/>
@@ -11752,6 +11893,7 @@
           <a:lstStyle/>
           <a:p>
             <a:pPr algn="ctr"/>
+            <a:endParaRPr/>
           </a:p>
         </p:txBody>
       </p:sp>
@@ -11772,7 +11914,7 @@
           <a:noFill/>
         </p:spPr>
         <p:txBody>
-          <a:bodyPr wrap="square" lIns="0" rIns="0" tIns="0" bIns="0" anchor="ctr">
+          <a:bodyPr wrap="square" lIns="0" tIns="0" rIns="0" bIns="0" anchor="ctr">
             <a:spAutoFit/>
           </a:bodyPr>
           <a:lstStyle/>
@@ -11839,6 +11981,7 @@
           <a:lstStyle/>
           <a:p>
             <a:pPr algn="ctr"/>
+            <a:endParaRPr/>
           </a:p>
         </p:txBody>
       </p:sp>
@@ -11859,7 +12002,7 @@
           <a:noFill/>
         </p:spPr>
         <p:txBody>
-          <a:bodyPr wrap="square" lIns="0" rIns="0" tIns="0" bIns="0" anchor="ctr">
+          <a:bodyPr wrap="square" lIns="0" tIns="0" rIns="0" bIns="0" anchor="ctr">
             <a:spAutoFit/>
           </a:bodyPr>
           <a:lstStyle/>
@@ -11926,6 +12069,7 @@
           <a:lstStyle/>
           <a:p>
             <a:pPr algn="ctr"/>
+            <a:endParaRPr/>
           </a:p>
         </p:txBody>
       </p:sp>
@@ -11946,7 +12090,7 @@
           <a:noFill/>
         </p:spPr>
         <p:txBody>
-          <a:bodyPr wrap="square" lIns="0" rIns="0" tIns="0" bIns="0" anchor="ctr">
+          <a:bodyPr wrap="square" lIns="0" tIns="0" rIns="0" bIns="0" anchor="ctr">
             <a:spAutoFit/>
           </a:bodyPr>
           <a:lstStyle/>
@@ -12013,6 +12157,7 @@
           <a:lstStyle/>
           <a:p>
             <a:pPr algn="ctr"/>
+            <a:endParaRPr/>
           </a:p>
         </p:txBody>
       </p:sp>
@@ -12033,7 +12178,7 @@
           <a:noFill/>
         </p:spPr>
         <p:txBody>
-          <a:bodyPr wrap="square" lIns="0" rIns="0" tIns="0" bIns="0" anchor="ctr">
+          <a:bodyPr wrap="square" lIns="0" tIns="0" rIns="0" bIns="0" anchor="ctr">
             <a:spAutoFit/>
           </a:bodyPr>
           <a:lstStyle/>
@@ -12100,6 +12245,7 @@
           <a:lstStyle/>
           <a:p>
             <a:pPr algn="ctr"/>
+            <a:endParaRPr/>
           </a:p>
         </p:txBody>
       </p:sp>
@@ -12120,7 +12266,7 @@
           <a:noFill/>
         </p:spPr>
         <p:txBody>
-          <a:bodyPr wrap="square" lIns="0" rIns="0" tIns="0" bIns="0" anchor="ctr">
+          <a:bodyPr wrap="square" lIns="0" tIns="0" rIns="0" bIns="0" anchor="ctr">
             <a:spAutoFit/>
           </a:bodyPr>
           <a:lstStyle/>
@@ -12187,6 +12333,7 @@
           <a:lstStyle/>
           <a:p>
             <a:pPr algn="ctr"/>
+            <a:endParaRPr/>
           </a:p>
         </p:txBody>
       </p:sp>
@@ -12207,7 +12354,7 @@
           <a:noFill/>
         </p:spPr>
         <p:txBody>
-          <a:bodyPr wrap="square" lIns="0" rIns="0" tIns="0" bIns="0" anchor="ctr">
+          <a:bodyPr wrap="square" lIns="0" tIns="0" rIns="0" bIns="0" anchor="ctr">
             <a:spAutoFit/>
           </a:bodyPr>
           <a:lstStyle/>
@@ -12274,6 +12421,7 @@
           <a:lstStyle/>
           <a:p>
             <a:pPr algn="ctr"/>
+            <a:endParaRPr/>
           </a:p>
         </p:txBody>
       </p:sp>
@@ -12294,7 +12442,7 @@
           <a:noFill/>
         </p:spPr>
         <p:txBody>
-          <a:bodyPr wrap="square" lIns="0" rIns="0" tIns="0" bIns="0" anchor="ctr">
+          <a:bodyPr wrap="square" lIns="0" tIns="0" rIns="0" bIns="0" anchor="ctr">
             <a:spAutoFit/>
           </a:bodyPr>
           <a:lstStyle/>
@@ -12361,6 +12509,7 @@
           <a:lstStyle/>
           <a:p>
             <a:pPr algn="ctr"/>
+            <a:endParaRPr/>
           </a:p>
         </p:txBody>
       </p:sp>
@@ -12381,7 +12530,7 @@
           <a:noFill/>
         </p:spPr>
         <p:txBody>
-          <a:bodyPr wrap="square" lIns="0" rIns="0" tIns="0" bIns="0" anchor="ctr">
+          <a:bodyPr wrap="square" lIns="0" tIns="0" rIns="0" bIns="0" anchor="ctr">
             <a:spAutoFit/>
           </a:bodyPr>
           <a:lstStyle/>
@@ -12448,6 +12597,7 @@
           <a:lstStyle/>
           <a:p>
             <a:pPr algn="ctr"/>
+            <a:endParaRPr/>
           </a:p>
         </p:txBody>
       </p:sp>
@@ -12468,7 +12618,7 @@
           <a:noFill/>
         </p:spPr>
         <p:txBody>
-          <a:bodyPr wrap="square" lIns="0" rIns="0" tIns="0" bIns="0" anchor="ctr">
+          <a:bodyPr wrap="square" lIns="0" tIns="0" rIns="0" bIns="0" anchor="ctr">
             <a:spAutoFit/>
           </a:bodyPr>
           <a:lstStyle/>
@@ -12535,6 +12685,7 @@
           <a:lstStyle/>
           <a:p>
             <a:pPr algn="ctr"/>
+            <a:endParaRPr/>
           </a:p>
         </p:txBody>
       </p:sp>
@@ -12555,7 +12706,7 @@
           <a:noFill/>
         </p:spPr>
         <p:txBody>
-          <a:bodyPr wrap="square" lIns="0" rIns="0" tIns="0" bIns="0" anchor="ctr">
+          <a:bodyPr wrap="square" lIns="0" tIns="0" rIns="0" bIns="0" anchor="ctr">
             <a:spAutoFit/>
           </a:bodyPr>
           <a:lstStyle/>
@@ -12585,7 +12736,7 @@
         </p:nvSpPr>
         <p:spPr>
           <a:xfrm>
-            <a:off x="777240" y="5907024"/>
+            <a:off x="777240" y="5729224"/>
             <a:ext cx="10607040" cy="822960"/>
           </a:xfrm>
           <a:prstGeom prst="rect">
@@ -12594,7 +12745,7 @@
           <a:noFill/>
         </p:spPr>
         <p:txBody>
-          <a:bodyPr wrap="square" lIns="0" rIns="0" tIns="0" bIns="0" anchor="t">
+          <a:bodyPr wrap="square" lIns="0" tIns="0" rIns="0" bIns="0" anchor="t">
             <a:spAutoFit/>
           </a:bodyPr>
           <a:lstStyle/>
@@ -12605,13 +12756,31 @@
               </a:lnSpc>
             </a:pPr>
             <a:r>
-              <a:rPr sz="1350" b="1">
+              <a:rPr sz="1350" b="1" dirty="0">
                 <a:solidFill>
                   <a:srgbClr val="26221E"/>
                 </a:solidFill>
                 <a:latin typeface="Segoe UI"/>
               </a:rPr>
-              <a:t>The AI layer stays in single-digit dollars until you're handling tens of thousands of conversations a month.  No licence fee.  No minimum.</a:t>
+              <a:t>The AI layer stays in single-digit dollars until you're handling tens of thousands of conversations a month.  No </a:t>
+            </a:r>
+            <a:r>
+              <a:rPr sz="1350" b="1" dirty="0" err="1">
+                <a:solidFill>
+                  <a:srgbClr val="26221E"/>
+                </a:solidFill>
+                <a:latin typeface="Segoe UI"/>
+              </a:rPr>
+              <a:t>licence</a:t>
+            </a:r>
+            <a:r>
+              <a:rPr sz="1350" b="1" dirty="0">
+                <a:solidFill>
+                  <a:srgbClr val="26221E"/>
+                </a:solidFill>
+                <a:latin typeface="Segoe UI"/>
+              </a:rPr>
+              <a:t> fee.  No minimum.</a:t>
             </a:r>
           </a:p>
         </p:txBody>
@@ -12633,7 +12802,7 @@
           <a:noFill/>
         </p:spPr>
         <p:txBody>
-          <a:bodyPr wrap="square" lIns="0" rIns="0" tIns="0" bIns="0" anchor="t">
+          <a:bodyPr wrap="square" lIns="0" tIns="0" rIns="0" bIns="0" anchor="t">
             <a:spAutoFit/>
           </a:bodyPr>
           <a:lstStyle/>

</xml_diff>